<commit_message>
chore: extended description of SplitBoundary in the users guide and added 2 Figures as illustrations.
</commit_message>
<xml_diff>
--- a/doc/figures/SplitBoundaryUG_fig12.pptx
+++ b/doc/figures/SplitBoundaryUG_fig12.pptx
@@ -104,6 +104,11 @@
       </a:defRPr>
     </a:lvl9pPr>
   </p:defaultTextStyle>
+  <p:extLst>
+    <p:ext uri="{EFAFB233-063F-42B5-8137-9DF3F51BA10A}">
+      <p15:sldGuideLst xmlns:p15="http://schemas.microsoft.com/office/powerpoint/2012/main"/>
+    </p:ext>
+  </p:extLst>
 </p:presentation>
 </file>
 
@@ -256,7 +261,7 @@
           <a:p>
             <a:fld id="{A923E91D-C2F6-8241-8A23-B73342C056DB}" type="datetimeFigureOut">
               <a:rPr lang="en-US" smtClean="0"/>
-              <a:t>1/22/20</a:t>
+              <a:t>1/25/20</a:t>
             </a:fld>
             <a:endParaRPr lang="en-US"/>
           </a:p>
@@ -456,7 +461,7 @@
           <a:p>
             <a:fld id="{A923E91D-C2F6-8241-8A23-B73342C056DB}" type="datetimeFigureOut">
               <a:rPr lang="en-US" smtClean="0"/>
-              <a:t>1/22/20</a:t>
+              <a:t>1/25/20</a:t>
             </a:fld>
             <a:endParaRPr lang="en-US"/>
           </a:p>
@@ -666,7 +671,7 @@
           <a:p>
             <a:fld id="{A923E91D-C2F6-8241-8A23-B73342C056DB}" type="datetimeFigureOut">
               <a:rPr lang="en-US" smtClean="0"/>
-              <a:t>1/22/20</a:t>
+              <a:t>1/25/20</a:t>
             </a:fld>
             <a:endParaRPr lang="en-US"/>
           </a:p>
@@ -866,7 +871,7 @@
           <a:p>
             <a:fld id="{A923E91D-C2F6-8241-8A23-B73342C056DB}" type="datetimeFigureOut">
               <a:rPr lang="en-US" smtClean="0"/>
-              <a:t>1/22/20</a:t>
+              <a:t>1/25/20</a:t>
             </a:fld>
             <a:endParaRPr lang="en-US"/>
           </a:p>
@@ -1142,7 +1147,7 @@
           <a:p>
             <a:fld id="{A923E91D-C2F6-8241-8A23-B73342C056DB}" type="datetimeFigureOut">
               <a:rPr lang="en-US" smtClean="0"/>
-              <a:t>1/22/20</a:t>
+              <a:t>1/25/20</a:t>
             </a:fld>
             <a:endParaRPr lang="en-US"/>
           </a:p>
@@ -1410,7 +1415,7 @@
           <a:p>
             <a:fld id="{A923E91D-C2F6-8241-8A23-B73342C056DB}" type="datetimeFigureOut">
               <a:rPr lang="en-US" smtClean="0"/>
-              <a:t>1/22/20</a:t>
+              <a:t>1/25/20</a:t>
             </a:fld>
             <a:endParaRPr lang="en-US"/>
           </a:p>
@@ -1825,7 +1830,7 @@
           <a:p>
             <a:fld id="{A923E91D-C2F6-8241-8A23-B73342C056DB}" type="datetimeFigureOut">
               <a:rPr lang="en-US" smtClean="0"/>
-              <a:t>1/22/20</a:t>
+              <a:t>1/25/20</a:t>
             </a:fld>
             <a:endParaRPr lang="en-US"/>
           </a:p>
@@ -1967,7 +1972,7 @@
           <a:p>
             <a:fld id="{A923E91D-C2F6-8241-8A23-B73342C056DB}" type="datetimeFigureOut">
               <a:rPr lang="en-US" smtClean="0"/>
-              <a:t>1/22/20</a:t>
+              <a:t>1/25/20</a:t>
             </a:fld>
             <a:endParaRPr lang="en-US"/>
           </a:p>
@@ -2080,7 +2085,7 @@
           <a:p>
             <a:fld id="{A923E91D-C2F6-8241-8A23-B73342C056DB}" type="datetimeFigureOut">
               <a:rPr lang="en-US" smtClean="0"/>
-              <a:t>1/22/20</a:t>
+              <a:t>1/25/20</a:t>
             </a:fld>
             <a:endParaRPr lang="en-US"/>
           </a:p>
@@ -2393,7 +2398,7 @@
           <a:p>
             <a:fld id="{A923E91D-C2F6-8241-8A23-B73342C056DB}" type="datetimeFigureOut">
               <a:rPr lang="en-US" smtClean="0"/>
-              <a:t>1/22/20</a:t>
+              <a:t>1/25/20</a:t>
             </a:fld>
             <a:endParaRPr lang="en-US"/>
           </a:p>
@@ -2682,7 +2687,7 @@
           <a:p>
             <a:fld id="{A923E91D-C2F6-8241-8A23-B73342C056DB}" type="datetimeFigureOut">
               <a:rPr lang="en-US" smtClean="0"/>
-              <a:t>1/22/20</a:t>
+              <a:t>1/25/20</a:t>
             </a:fld>
             <a:endParaRPr lang="en-US"/>
           </a:p>
@@ -2925,7 +2930,7 @@
           <a:p>
             <a:fld id="{A923E91D-C2F6-8241-8A23-B73342C056DB}" type="datetimeFigureOut">
               <a:rPr lang="en-US" smtClean="0"/>
-              <a:t>1/22/20</a:t>
+              <a:t>1/25/20</a:t>
             </a:fld>
             <a:endParaRPr lang="en-US"/>
           </a:p>
@@ -3342,53 +3347,2470 @@
           <a:chExt cx="0" cy="0"/>
         </a:xfrm>
       </p:grpSpPr>
-      <p:sp>
-        <p:nvSpPr>
-          <p:cNvPr id="2" name="Title 1">
-            <a:extLst>
-              <a:ext uri="{FF2B5EF4-FFF2-40B4-BE49-F238E27FC236}">
-                <a16:creationId xmlns:a16="http://schemas.microsoft.com/office/drawing/2014/main" id="{3CF24286-0C62-C742-B7AC-8CE00135625E}"/>
-              </a:ext>
-            </a:extLst>
-          </p:cNvPr>
-          <p:cNvSpPr>
-            <a:spLocks noGrp="1"/>
-          </p:cNvSpPr>
-          <p:nvPr>
-            <p:ph type="ctrTitle"/>
-          </p:nvPr>
-        </p:nvSpPr>
-        <p:spPr/>
-        <p:txBody>
-          <a:bodyPr/>
-          <a:lstStyle/>
-          <a:p>
-            <a:endParaRPr lang="en-US"/>
-          </a:p>
-        </p:txBody>
-      </p:sp>
-      <p:sp>
-        <p:nvSpPr>
-          <p:cNvPr id="3" name="Subtitle 2">
-            <a:extLst>
-              <a:ext uri="{FF2B5EF4-FFF2-40B4-BE49-F238E27FC236}">
-                <a16:creationId xmlns:a16="http://schemas.microsoft.com/office/drawing/2014/main" id="{921584C8-F6E9-D248-BDA9-393B6C47E246}"/>
-              </a:ext>
-            </a:extLst>
-          </p:cNvPr>
-          <p:cNvSpPr>
-            <a:spLocks noGrp="1"/>
-          </p:cNvSpPr>
-          <p:nvPr>
-            <p:ph type="subTitle" idx="1"/>
-          </p:nvPr>
-        </p:nvSpPr>
-        <p:spPr/>
-        <p:txBody>
-          <a:bodyPr/>
-          <a:lstStyle/>
-          <a:p>
-            <a:endParaRPr lang="en-US"/>
+      <p:pic>
+        <p:nvPicPr>
+          <p:cNvPr id="2" name="Picture 1">
+            <a:extLst>
+              <a:ext uri="{FF2B5EF4-FFF2-40B4-BE49-F238E27FC236}">
+                <a16:creationId xmlns:a16="http://schemas.microsoft.com/office/drawing/2014/main" id="{524EB329-0E20-3E4A-9F13-D438DA444D5E}"/>
+              </a:ext>
+            </a:extLst>
+          </p:cNvPr>
+          <p:cNvPicPr>
+            <a:picLocks noChangeAspect="1"/>
+          </p:cNvPicPr>
+          <p:nvPr/>
+        </p:nvPicPr>
+        <p:blipFill rotWithShape="1">
+          <a:blip r:embed="rId2"/>
+          <a:srcRect t="28448" b="22795"/>
+          <a:stretch/>
+        </p:blipFill>
+        <p:spPr>
+          <a:xfrm>
+            <a:off x="2615765" y="1676400"/>
+            <a:ext cx="7189069" cy="3505200"/>
+          </a:xfrm>
+          <a:prstGeom prst="rect">
+            <a:avLst/>
+          </a:prstGeom>
+          <a:ln w="19050">
+            <a:solidFill>
+              <a:schemeClr val="tx1"/>
+            </a:solidFill>
+          </a:ln>
+        </p:spPr>
+      </p:pic>
+      <p:sp>
+        <p:nvSpPr>
+          <p:cNvPr id="6" name="Chord 5">
+            <a:extLst>
+              <a:ext uri="{FF2B5EF4-FFF2-40B4-BE49-F238E27FC236}">
+                <a16:creationId xmlns:a16="http://schemas.microsoft.com/office/drawing/2014/main" id="{67C57186-3610-834E-A156-393DBB9A5108}"/>
+              </a:ext>
+            </a:extLst>
+          </p:cNvPr>
+          <p:cNvSpPr/>
+          <p:nvPr/>
+        </p:nvSpPr>
+        <p:spPr>
+          <a:xfrm rot="5801687">
+            <a:off x="8251584" y="2821015"/>
+            <a:ext cx="255722" cy="286719"/>
+          </a:xfrm>
+          <a:prstGeom prst="chord">
+            <a:avLst/>
+          </a:prstGeom>
+          <a:solidFill>
+            <a:srgbClr val="00B050"/>
+          </a:solidFill>
+        </p:spPr>
+        <p:style>
+          <a:lnRef idx="2">
+            <a:schemeClr val="accent1">
+              <a:shade val="50000"/>
+            </a:schemeClr>
+          </a:lnRef>
+          <a:fillRef idx="1">
+            <a:schemeClr val="accent1"/>
+          </a:fillRef>
+          <a:effectRef idx="0">
+            <a:schemeClr val="accent1"/>
+          </a:effectRef>
+          <a:fontRef idx="minor">
+            <a:schemeClr val="lt1"/>
+          </a:fontRef>
+        </p:style>
+        <p:txBody>
+          <a:bodyPr rtlCol="0" anchor="ctr"/>
+          <a:lstStyle/>
+          <a:p>
+            <a:pPr algn="ctr"/>
+            <a:endParaRPr lang="en-US"/>
+          </a:p>
+        </p:txBody>
+      </p:sp>
+      <p:sp>
+        <p:nvSpPr>
+          <p:cNvPr id="44" name="Chord 43">
+            <a:extLst>
+              <a:ext uri="{FF2B5EF4-FFF2-40B4-BE49-F238E27FC236}">
+                <a16:creationId xmlns:a16="http://schemas.microsoft.com/office/drawing/2014/main" id="{D93A7DE7-5F69-8F42-81D2-770CA8658211}"/>
+              </a:ext>
+            </a:extLst>
+          </p:cNvPr>
+          <p:cNvSpPr/>
+          <p:nvPr/>
+        </p:nvSpPr>
+        <p:spPr>
+          <a:xfrm rot="5789241" flipH="1" flipV="1">
+            <a:off x="8319083" y="2991053"/>
+            <a:ext cx="255722" cy="286719"/>
+          </a:xfrm>
+          <a:prstGeom prst="chord">
+            <a:avLst/>
+          </a:prstGeom>
+          <a:solidFill>
+            <a:srgbClr val="FFFF00"/>
+          </a:solidFill>
+        </p:spPr>
+        <p:style>
+          <a:lnRef idx="2">
+            <a:schemeClr val="accent1">
+              <a:shade val="50000"/>
+            </a:schemeClr>
+          </a:lnRef>
+          <a:fillRef idx="1">
+            <a:schemeClr val="accent1"/>
+          </a:fillRef>
+          <a:effectRef idx="0">
+            <a:schemeClr val="accent1"/>
+          </a:effectRef>
+          <a:fontRef idx="minor">
+            <a:schemeClr val="lt1"/>
+          </a:fontRef>
+        </p:style>
+        <p:txBody>
+          <a:bodyPr rtlCol="0" anchor="ctr"/>
+          <a:lstStyle/>
+          <a:p>
+            <a:pPr algn="ctr"/>
+            <a:endParaRPr lang="en-US"/>
+          </a:p>
+        </p:txBody>
+      </p:sp>
+      <p:grpSp>
+        <p:nvGrpSpPr>
+          <p:cNvPr id="8" name="Group 7">
+            <a:extLst>
+              <a:ext uri="{FF2B5EF4-FFF2-40B4-BE49-F238E27FC236}">
+                <a16:creationId xmlns:a16="http://schemas.microsoft.com/office/drawing/2014/main" id="{541D774E-8A07-FD40-8F38-DCC7810BAB03}"/>
+              </a:ext>
+            </a:extLst>
+          </p:cNvPr>
+          <p:cNvGrpSpPr/>
+          <p:nvPr/>
+        </p:nvGrpSpPr>
+        <p:grpSpPr>
+          <a:xfrm>
+            <a:off x="7584017" y="3003240"/>
+            <a:ext cx="354218" cy="425760"/>
+            <a:chOff x="8388485" y="2988914"/>
+            <a:chExt cx="354218" cy="425760"/>
+          </a:xfrm>
+        </p:grpSpPr>
+        <p:sp>
+          <p:nvSpPr>
+            <p:cNvPr id="45" name="Chord 44">
+              <a:extLst>
+                <a:ext uri="{FF2B5EF4-FFF2-40B4-BE49-F238E27FC236}">
+                  <a16:creationId xmlns:a16="http://schemas.microsoft.com/office/drawing/2014/main" id="{29073046-8A2A-FE46-93A2-41BD2B506D70}"/>
+                </a:ext>
+              </a:extLst>
+            </p:cNvPr>
+            <p:cNvSpPr/>
+            <p:nvPr/>
+          </p:nvSpPr>
+          <p:spPr>
+            <a:xfrm rot="5801687">
+              <a:off x="8403984" y="2973415"/>
+              <a:ext cx="255722" cy="286719"/>
+            </a:xfrm>
+            <a:prstGeom prst="chord">
+              <a:avLst/>
+            </a:prstGeom>
+            <a:solidFill>
+              <a:srgbClr val="00B050"/>
+            </a:solidFill>
+          </p:spPr>
+          <p:style>
+            <a:lnRef idx="2">
+              <a:schemeClr val="accent1">
+                <a:shade val="50000"/>
+              </a:schemeClr>
+            </a:lnRef>
+            <a:fillRef idx="1">
+              <a:schemeClr val="accent1"/>
+            </a:fillRef>
+            <a:effectRef idx="0">
+              <a:schemeClr val="accent1"/>
+            </a:effectRef>
+            <a:fontRef idx="minor">
+              <a:schemeClr val="lt1"/>
+            </a:fontRef>
+          </p:style>
+          <p:txBody>
+            <a:bodyPr rtlCol="0" anchor="ctr"/>
+            <a:lstStyle/>
+            <a:p>
+              <a:pPr algn="ctr"/>
+              <a:endParaRPr lang="en-US"/>
+            </a:p>
+          </p:txBody>
+        </p:sp>
+        <p:sp>
+          <p:nvSpPr>
+            <p:cNvPr id="46" name="Chord 45">
+              <a:extLst>
+                <a:ext uri="{FF2B5EF4-FFF2-40B4-BE49-F238E27FC236}">
+                  <a16:creationId xmlns:a16="http://schemas.microsoft.com/office/drawing/2014/main" id="{B011B9CF-1DE7-124E-B783-4D5B73ADD6E0}"/>
+                </a:ext>
+              </a:extLst>
+            </p:cNvPr>
+            <p:cNvSpPr/>
+            <p:nvPr/>
+          </p:nvSpPr>
+          <p:spPr>
+            <a:xfrm rot="5789241" flipH="1" flipV="1">
+              <a:off x="8471483" y="3143453"/>
+              <a:ext cx="255722" cy="286719"/>
+            </a:xfrm>
+            <a:prstGeom prst="chord">
+              <a:avLst/>
+            </a:prstGeom>
+            <a:solidFill>
+              <a:srgbClr val="FFFF00"/>
+            </a:solidFill>
+          </p:spPr>
+          <p:style>
+            <a:lnRef idx="2">
+              <a:schemeClr val="accent1">
+                <a:shade val="50000"/>
+              </a:schemeClr>
+            </a:lnRef>
+            <a:fillRef idx="1">
+              <a:schemeClr val="accent1"/>
+            </a:fillRef>
+            <a:effectRef idx="0">
+              <a:schemeClr val="accent1"/>
+            </a:effectRef>
+            <a:fontRef idx="minor">
+              <a:schemeClr val="lt1"/>
+            </a:fontRef>
+          </p:style>
+          <p:txBody>
+            <a:bodyPr rtlCol="0" anchor="ctr"/>
+            <a:lstStyle/>
+            <a:p>
+              <a:pPr algn="ctr"/>
+              <a:endParaRPr lang="en-US"/>
+            </a:p>
+          </p:txBody>
+        </p:sp>
+      </p:grpSp>
+      <p:grpSp>
+        <p:nvGrpSpPr>
+          <p:cNvPr id="47" name="Group 46">
+            <a:extLst>
+              <a:ext uri="{FF2B5EF4-FFF2-40B4-BE49-F238E27FC236}">
+                <a16:creationId xmlns:a16="http://schemas.microsoft.com/office/drawing/2014/main" id="{0B189B2E-5FB7-BF4C-A811-47DB63FD9DAC}"/>
+              </a:ext>
+            </a:extLst>
+          </p:cNvPr>
+          <p:cNvGrpSpPr/>
+          <p:nvPr/>
+        </p:nvGrpSpPr>
+        <p:grpSpPr>
+          <a:xfrm>
+            <a:off x="6888468" y="3192873"/>
+            <a:ext cx="354218" cy="425760"/>
+            <a:chOff x="8388485" y="2988914"/>
+            <a:chExt cx="354218" cy="425760"/>
+          </a:xfrm>
+        </p:grpSpPr>
+        <p:sp>
+          <p:nvSpPr>
+            <p:cNvPr id="48" name="Chord 47">
+              <a:extLst>
+                <a:ext uri="{FF2B5EF4-FFF2-40B4-BE49-F238E27FC236}">
+                  <a16:creationId xmlns:a16="http://schemas.microsoft.com/office/drawing/2014/main" id="{C19A910C-2900-074F-9B60-34BBEBF142F6}"/>
+                </a:ext>
+              </a:extLst>
+            </p:cNvPr>
+            <p:cNvSpPr/>
+            <p:nvPr/>
+          </p:nvSpPr>
+          <p:spPr>
+            <a:xfrm rot="5801687">
+              <a:off x="8403984" y="2973415"/>
+              <a:ext cx="255722" cy="286719"/>
+            </a:xfrm>
+            <a:prstGeom prst="chord">
+              <a:avLst/>
+            </a:prstGeom>
+            <a:solidFill>
+              <a:srgbClr val="00B050"/>
+            </a:solidFill>
+          </p:spPr>
+          <p:style>
+            <a:lnRef idx="2">
+              <a:schemeClr val="accent1">
+                <a:shade val="50000"/>
+              </a:schemeClr>
+            </a:lnRef>
+            <a:fillRef idx="1">
+              <a:schemeClr val="accent1"/>
+            </a:fillRef>
+            <a:effectRef idx="0">
+              <a:schemeClr val="accent1"/>
+            </a:effectRef>
+            <a:fontRef idx="minor">
+              <a:schemeClr val="lt1"/>
+            </a:fontRef>
+          </p:style>
+          <p:txBody>
+            <a:bodyPr rtlCol="0" anchor="ctr"/>
+            <a:lstStyle/>
+            <a:p>
+              <a:pPr algn="ctr"/>
+              <a:endParaRPr lang="en-US"/>
+            </a:p>
+          </p:txBody>
+        </p:sp>
+        <p:sp>
+          <p:nvSpPr>
+            <p:cNvPr id="49" name="Chord 48">
+              <a:extLst>
+                <a:ext uri="{FF2B5EF4-FFF2-40B4-BE49-F238E27FC236}">
+                  <a16:creationId xmlns:a16="http://schemas.microsoft.com/office/drawing/2014/main" id="{D878F4B8-2C0F-D240-8CC5-3800B9FA72C0}"/>
+                </a:ext>
+              </a:extLst>
+            </p:cNvPr>
+            <p:cNvSpPr/>
+            <p:nvPr/>
+          </p:nvSpPr>
+          <p:spPr>
+            <a:xfrm rot="5789241" flipH="1" flipV="1">
+              <a:off x="8471483" y="3143453"/>
+              <a:ext cx="255722" cy="286719"/>
+            </a:xfrm>
+            <a:prstGeom prst="chord">
+              <a:avLst/>
+            </a:prstGeom>
+            <a:solidFill>
+              <a:srgbClr val="FFFF00"/>
+            </a:solidFill>
+          </p:spPr>
+          <p:style>
+            <a:lnRef idx="2">
+              <a:schemeClr val="accent1">
+                <a:shade val="50000"/>
+              </a:schemeClr>
+            </a:lnRef>
+            <a:fillRef idx="1">
+              <a:schemeClr val="accent1"/>
+            </a:fillRef>
+            <a:effectRef idx="0">
+              <a:schemeClr val="accent1"/>
+            </a:effectRef>
+            <a:fontRef idx="minor">
+              <a:schemeClr val="lt1"/>
+            </a:fontRef>
+          </p:style>
+          <p:txBody>
+            <a:bodyPr rtlCol="0" anchor="ctr"/>
+            <a:lstStyle/>
+            <a:p>
+              <a:pPr algn="ctr"/>
+              <a:endParaRPr lang="en-US"/>
+            </a:p>
+          </p:txBody>
+        </p:sp>
+      </p:grpSp>
+      <p:cxnSp>
+        <p:nvCxnSpPr>
+          <p:cNvPr id="25" name="Straight Connector 24">
+            <a:extLst>
+              <a:ext uri="{FF2B5EF4-FFF2-40B4-BE49-F238E27FC236}">
+                <a16:creationId xmlns:a16="http://schemas.microsoft.com/office/drawing/2014/main" id="{5AD5875D-A9FE-4447-BBCF-EA1A29612ED1}"/>
+              </a:ext>
+            </a:extLst>
+          </p:cNvPr>
+          <p:cNvCxnSpPr>
+            <a:cxnSpLocks/>
+          </p:cNvCxnSpPr>
+          <p:nvPr/>
+        </p:nvCxnSpPr>
+        <p:spPr>
+          <a:xfrm flipH="1" flipV="1">
+            <a:off x="5021453" y="1676402"/>
+            <a:ext cx="1332135" cy="1862377"/>
+          </a:xfrm>
+          <a:prstGeom prst="line">
+            <a:avLst/>
+          </a:prstGeom>
+          <a:ln w="57150">
+            <a:solidFill>
+              <a:schemeClr val="accent5">
+                <a:lumMod val="75000"/>
+              </a:schemeClr>
+            </a:solidFill>
+          </a:ln>
+        </p:spPr>
+        <p:style>
+          <a:lnRef idx="1">
+            <a:schemeClr val="accent1"/>
+          </a:lnRef>
+          <a:fillRef idx="0">
+            <a:schemeClr val="accent1"/>
+          </a:fillRef>
+          <a:effectRef idx="0">
+            <a:schemeClr val="accent1"/>
+          </a:effectRef>
+          <a:fontRef idx="minor">
+            <a:schemeClr val="tx1"/>
+          </a:fontRef>
+        </p:style>
+      </p:cxnSp>
+      <p:grpSp>
+        <p:nvGrpSpPr>
+          <p:cNvPr id="50" name="Group 49">
+            <a:extLst>
+              <a:ext uri="{FF2B5EF4-FFF2-40B4-BE49-F238E27FC236}">
+                <a16:creationId xmlns:a16="http://schemas.microsoft.com/office/drawing/2014/main" id="{E225971E-29A4-954C-AE91-26C2970DC441}"/>
+              </a:ext>
+            </a:extLst>
+          </p:cNvPr>
+          <p:cNvGrpSpPr/>
+          <p:nvPr/>
+        </p:nvGrpSpPr>
+        <p:grpSpPr>
+          <a:xfrm>
+            <a:off x="5525909" y="3554277"/>
+            <a:ext cx="354218" cy="425760"/>
+            <a:chOff x="8388485" y="2988914"/>
+            <a:chExt cx="354218" cy="425760"/>
+          </a:xfrm>
+        </p:grpSpPr>
+        <p:sp>
+          <p:nvSpPr>
+            <p:cNvPr id="51" name="Chord 50">
+              <a:extLst>
+                <a:ext uri="{FF2B5EF4-FFF2-40B4-BE49-F238E27FC236}">
+                  <a16:creationId xmlns:a16="http://schemas.microsoft.com/office/drawing/2014/main" id="{BF89DF20-0198-B14F-A849-817D6B3ED5F9}"/>
+                </a:ext>
+              </a:extLst>
+            </p:cNvPr>
+            <p:cNvSpPr/>
+            <p:nvPr/>
+          </p:nvSpPr>
+          <p:spPr>
+            <a:xfrm rot="5801687">
+              <a:off x="8403984" y="2973415"/>
+              <a:ext cx="255722" cy="286719"/>
+            </a:xfrm>
+            <a:prstGeom prst="chord">
+              <a:avLst/>
+            </a:prstGeom>
+            <a:solidFill>
+              <a:srgbClr val="00B050"/>
+            </a:solidFill>
+          </p:spPr>
+          <p:style>
+            <a:lnRef idx="2">
+              <a:schemeClr val="accent1">
+                <a:shade val="50000"/>
+              </a:schemeClr>
+            </a:lnRef>
+            <a:fillRef idx="1">
+              <a:schemeClr val="accent1"/>
+            </a:fillRef>
+            <a:effectRef idx="0">
+              <a:schemeClr val="accent1"/>
+            </a:effectRef>
+            <a:fontRef idx="minor">
+              <a:schemeClr val="lt1"/>
+            </a:fontRef>
+          </p:style>
+          <p:txBody>
+            <a:bodyPr rtlCol="0" anchor="ctr"/>
+            <a:lstStyle/>
+            <a:p>
+              <a:pPr algn="ctr"/>
+              <a:endParaRPr lang="en-US"/>
+            </a:p>
+          </p:txBody>
+        </p:sp>
+        <p:sp>
+          <p:nvSpPr>
+            <p:cNvPr id="52" name="Chord 51">
+              <a:extLst>
+                <a:ext uri="{FF2B5EF4-FFF2-40B4-BE49-F238E27FC236}">
+                  <a16:creationId xmlns:a16="http://schemas.microsoft.com/office/drawing/2014/main" id="{7085B582-DBFA-9A4A-B300-8AB5EF543EAB}"/>
+                </a:ext>
+              </a:extLst>
+            </p:cNvPr>
+            <p:cNvSpPr/>
+            <p:nvPr/>
+          </p:nvSpPr>
+          <p:spPr>
+            <a:xfrm rot="5789241" flipH="1" flipV="1">
+              <a:off x="8471483" y="3143453"/>
+              <a:ext cx="255722" cy="286719"/>
+            </a:xfrm>
+            <a:prstGeom prst="chord">
+              <a:avLst/>
+            </a:prstGeom>
+            <a:solidFill>
+              <a:srgbClr val="FFFF00"/>
+            </a:solidFill>
+          </p:spPr>
+          <p:style>
+            <a:lnRef idx="2">
+              <a:schemeClr val="accent1">
+                <a:shade val="50000"/>
+              </a:schemeClr>
+            </a:lnRef>
+            <a:fillRef idx="1">
+              <a:schemeClr val="accent1"/>
+            </a:fillRef>
+            <a:effectRef idx="0">
+              <a:schemeClr val="accent1"/>
+            </a:effectRef>
+            <a:fontRef idx="minor">
+              <a:schemeClr val="lt1"/>
+            </a:fontRef>
+          </p:style>
+          <p:txBody>
+            <a:bodyPr rtlCol="0" anchor="ctr"/>
+            <a:lstStyle/>
+            <a:p>
+              <a:pPr algn="ctr"/>
+              <a:endParaRPr lang="en-US"/>
+            </a:p>
+          </p:txBody>
+        </p:sp>
+      </p:grpSp>
+      <p:grpSp>
+        <p:nvGrpSpPr>
+          <p:cNvPr id="53" name="Group 52">
+            <a:extLst>
+              <a:ext uri="{FF2B5EF4-FFF2-40B4-BE49-F238E27FC236}">
+                <a16:creationId xmlns:a16="http://schemas.microsoft.com/office/drawing/2014/main" id="{5323B2C6-F455-464B-8B90-5E37F8104359}"/>
+              </a:ext>
+            </a:extLst>
+          </p:cNvPr>
+          <p:cNvGrpSpPr/>
+          <p:nvPr/>
+        </p:nvGrpSpPr>
+        <p:grpSpPr>
+          <a:xfrm>
+            <a:off x="4171099" y="3923430"/>
+            <a:ext cx="354218" cy="425760"/>
+            <a:chOff x="8388485" y="2988914"/>
+            <a:chExt cx="354218" cy="425760"/>
+          </a:xfrm>
+        </p:grpSpPr>
+        <p:sp>
+          <p:nvSpPr>
+            <p:cNvPr id="54" name="Chord 53">
+              <a:extLst>
+                <a:ext uri="{FF2B5EF4-FFF2-40B4-BE49-F238E27FC236}">
+                  <a16:creationId xmlns:a16="http://schemas.microsoft.com/office/drawing/2014/main" id="{FC65A544-18F2-7145-B899-AF5D0A15ACB5}"/>
+                </a:ext>
+              </a:extLst>
+            </p:cNvPr>
+            <p:cNvSpPr/>
+            <p:nvPr/>
+          </p:nvSpPr>
+          <p:spPr>
+            <a:xfrm rot="5801687">
+              <a:off x="8403984" y="2973415"/>
+              <a:ext cx="255722" cy="286719"/>
+            </a:xfrm>
+            <a:prstGeom prst="chord">
+              <a:avLst/>
+            </a:prstGeom>
+            <a:solidFill>
+              <a:srgbClr val="00B050"/>
+            </a:solidFill>
+          </p:spPr>
+          <p:style>
+            <a:lnRef idx="2">
+              <a:schemeClr val="accent1">
+                <a:shade val="50000"/>
+              </a:schemeClr>
+            </a:lnRef>
+            <a:fillRef idx="1">
+              <a:schemeClr val="accent1"/>
+            </a:fillRef>
+            <a:effectRef idx="0">
+              <a:schemeClr val="accent1"/>
+            </a:effectRef>
+            <a:fontRef idx="minor">
+              <a:schemeClr val="lt1"/>
+            </a:fontRef>
+          </p:style>
+          <p:txBody>
+            <a:bodyPr rtlCol="0" anchor="ctr"/>
+            <a:lstStyle/>
+            <a:p>
+              <a:pPr algn="ctr"/>
+              <a:endParaRPr lang="en-US"/>
+            </a:p>
+          </p:txBody>
+        </p:sp>
+        <p:sp>
+          <p:nvSpPr>
+            <p:cNvPr id="55" name="Chord 54">
+              <a:extLst>
+                <a:ext uri="{FF2B5EF4-FFF2-40B4-BE49-F238E27FC236}">
+                  <a16:creationId xmlns:a16="http://schemas.microsoft.com/office/drawing/2014/main" id="{8256E49F-C7EB-7C44-A9A2-B17EA65AD822}"/>
+                </a:ext>
+              </a:extLst>
+            </p:cNvPr>
+            <p:cNvSpPr/>
+            <p:nvPr/>
+          </p:nvSpPr>
+          <p:spPr>
+            <a:xfrm rot="5789241" flipH="1" flipV="1">
+              <a:off x="8471483" y="3143453"/>
+              <a:ext cx="255722" cy="286719"/>
+            </a:xfrm>
+            <a:prstGeom prst="chord">
+              <a:avLst/>
+            </a:prstGeom>
+            <a:solidFill>
+              <a:srgbClr val="FFFF00"/>
+            </a:solidFill>
+          </p:spPr>
+          <p:style>
+            <a:lnRef idx="2">
+              <a:schemeClr val="accent1">
+                <a:shade val="50000"/>
+              </a:schemeClr>
+            </a:lnRef>
+            <a:fillRef idx="1">
+              <a:schemeClr val="accent1"/>
+            </a:fillRef>
+            <a:effectRef idx="0">
+              <a:schemeClr val="accent1"/>
+            </a:effectRef>
+            <a:fontRef idx="minor">
+              <a:schemeClr val="lt1"/>
+            </a:fontRef>
+          </p:style>
+          <p:txBody>
+            <a:bodyPr rtlCol="0" anchor="ctr"/>
+            <a:lstStyle/>
+            <a:p>
+              <a:pPr algn="ctr"/>
+              <a:endParaRPr lang="en-US"/>
+            </a:p>
+          </p:txBody>
+        </p:sp>
+      </p:grpSp>
+      <p:grpSp>
+        <p:nvGrpSpPr>
+          <p:cNvPr id="56" name="Group 55">
+            <a:extLst>
+              <a:ext uri="{FF2B5EF4-FFF2-40B4-BE49-F238E27FC236}">
+                <a16:creationId xmlns:a16="http://schemas.microsoft.com/office/drawing/2014/main" id="{4B83D932-ECCF-4940-AAE7-BFB735EC8F5A}"/>
+              </a:ext>
+            </a:extLst>
+          </p:cNvPr>
+          <p:cNvGrpSpPr/>
+          <p:nvPr/>
+        </p:nvGrpSpPr>
+        <p:grpSpPr>
+          <a:xfrm>
+            <a:off x="4836595" y="3738237"/>
+            <a:ext cx="354218" cy="425760"/>
+            <a:chOff x="8388485" y="2988914"/>
+            <a:chExt cx="354218" cy="425760"/>
+          </a:xfrm>
+        </p:grpSpPr>
+        <p:sp>
+          <p:nvSpPr>
+            <p:cNvPr id="57" name="Chord 56">
+              <a:extLst>
+                <a:ext uri="{FF2B5EF4-FFF2-40B4-BE49-F238E27FC236}">
+                  <a16:creationId xmlns:a16="http://schemas.microsoft.com/office/drawing/2014/main" id="{E6608653-86C5-424B-93A2-4528B70AA2E4}"/>
+                </a:ext>
+              </a:extLst>
+            </p:cNvPr>
+            <p:cNvSpPr/>
+            <p:nvPr/>
+          </p:nvSpPr>
+          <p:spPr>
+            <a:xfrm rot="5801687">
+              <a:off x="8403984" y="2973415"/>
+              <a:ext cx="255722" cy="286719"/>
+            </a:xfrm>
+            <a:prstGeom prst="chord">
+              <a:avLst/>
+            </a:prstGeom>
+            <a:solidFill>
+              <a:srgbClr val="00B050"/>
+            </a:solidFill>
+          </p:spPr>
+          <p:style>
+            <a:lnRef idx="2">
+              <a:schemeClr val="accent1">
+                <a:shade val="50000"/>
+              </a:schemeClr>
+            </a:lnRef>
+            <a:fillRef idx="1">
+              <a:schemeClr val="accent1"/>
+            </a:fillRef>
+            <a:effectRef idx="0">
+              <a:schemeClr val="accent1"/>
+            </a:effectRef>
+            <a:fontRef idx="minor">
+              <a:schemeClr val="lt1"/>
+            </a:fontRef>
+          </p:style>
+          <p:txBody>
+            <a:bodyPr rtlCol="0" anchor="ctr"/>
+            <a:lstStyle/>
+            <a:p>
+              <a:pPr algn="ctr"/>
+              <a:endParaRPr lang="en-US"/>
+            </a:p>
+          </p:txBody>
+        </p:sp>
+        <p:sp>
+          <p:nvSpPr>
+            <p:cNvPr id="58" name="Chord 57">
+              <a:extLst>
+                <a:ext uri="{FF2B5EF4-FFF2-40B4-BE49-F238E27FC236}">
+                  <a16:creationId xmlns:a16="http://schemas.microsoft.com/office/drawing/2014/main" id="{4C389952-0113-CE46-8E54-DBC1CC389703}"/>
+                </a:ext>
+              </a:extLst>
+            </p:cNvPr>
+            <p:cNvSpPr/>
+            <p:nvPr/>
+          </p:nvSpPr>
+          <p:spPr>
+            <a:xfrm rot="5789241" flipH="1" flipV="1">
+              <a:off x="8471483" y="3143453"/>
+              <a:ext cx="255722" cy="286719"/>
+            </a:xfrm>
+            <a:prstGeom prst="chord">
+              <a:avLst/>
+            </a:prstGeom>
+            <a:solidFill>
+              <a:srgbClr val="FFFF00"/>
+            </a:solidFill>
+          </p:spPr>
+          <p:style>
+            <a:lnRef idx="2">
+              <a:schemeClr val="accent1">
+                <a:shade val="50000"/>
+              </a:schemeClr>
+            </a:lnRef>
+            <a:fillRef idx="1">
+              <a:schemeClr val="accent1"/>
+            </a:fillRef>
+            <a:effectRef idx="0">
+              <a:schemeClr val="accent1"/>
+            </a:effectRef>
+            <a:fontRef idx="minor">
+              <a:schemeClr val="lt1"/>
+            </a:fontRef>
+          </p:style>
+          <p:txBody>
+            <a:bodyPr rtlCol="0" anchor="ctr"/>
+            <a:lstStyle/>
+            <a:p>
+              <a:pPr algn="ctr"/>
+              <a:endParaRPr lang="en-US"/>
+            </a:p>
+          </p:txBody>
+        </p:sp>
+      </p:grpSp>
+      <p:sp>
+        <p:nvSpPr>
+          <p:cNvPr id="60" name="Chord 59">
+            <a:extLst>
+              <a:ext uri="{FF2B5EF4-FFF2-40B4-BE49-F238E27FC236}">
+                <a16:creationId xmlns:a16="http://schemas.microsoft.com/office/drawing/2014/main" id="{EB330ADE-173A-E54A-8C0A-5D327291BD49}"/>
+              </a:ext>
+            </a:extLst>
+          </p:cNvPr>
+          <p:cNvSpPr/>
+          <p:nvPr/>
+        </p:nvSpPr>
+        <p:spPr>
+          <a:xfrm rot="5789241" flipH="1" flipV="1">
+            <a:off x="6274868" y="3531150"/>
+            <a:ext cx="255722" cy="286719"/>
+          </a:xfrm>
+          <a:prstGeom prst="chord">
+            <a:avLst/>
+          </a:prstGeom>
+          <a:solidFill>
+            <a:srgbClr val="FFFF00"/>
+          </a:solidFill>
+        </p:spPr>
+        <p:style>
+          <a:lnRef idx="2">
+            <a:schemeClr val="accent1">
+              <a:shade val="50000"/>
+            </a:schemeClr>
+          </a:lnRef>
+          <a:fillRef idx="1">
+            <a:schemeClr val="accent1"/>
+          </a:fillRef>
+          <a:effectRef idx="0">
+            <a:schemeClr val="accent1"/>
+          </a:effectRef>
+          <a:fontRef idx="minor">
+            <a:schemeClr val="lt1"/>
+          </a:fontRef>
+        </p:style>
+        <p:txBody>
+          <a:bodyPr rtlCol="0" anchor="ctr"/>
+          <a:lstStyle/>
+          <a:p>
+            <a:pPr algn="ctr"/>
+            <a:endParaRPr lang="en-US"/>
+          </a:p>
+        </p:txBody>
+      </p:sp>
+      <p:sp>
+        <p:nvSpPr>
+          <p:cNvPr id="67" name="Chord 66">
+            <a:extLst>
+              <a:ext uri="{FF2B5EF4-FFF2-40B4-BE49-F238E27FC236}">
+                <a16:creationId xmlns:a16="http://schemas.microsoft.com/office/drawing/2014/main" id="{B6021617-B670-F544-BA19-41C3B1141319}"/>
+              </a:ext>
+            </a:extLst>
+          </p:cNvPr>
+          <p:cNvSpPr/>
+          <p:nvPr/>
+        </p:nvSpPr>
+        <p:spPr>
+          <a:xfrm rot="5801687">
+            <a:off x="6219648" y="3356290"/>
+            <a:ext cx="255722" cy="286719"/>
+          </a:xfrm>
+          <a:prstGeom prst="chord">
+            <a:avLst/>
+          </a:prstGeom>
+          <a:solidFill>
+            <a:srgbClr val="00B050"/>
+          </a:solidFill>
+        </p:spPr>
+        <p:style>
+          <a:lnRef idx="2">
+            <a:schemeClr val="accent1">
+              <a:shade val="50000"/>
+            </a:schemeClr>
+          </a:lnRef>
+          <a:fillRef idx="1">
+            <a:schemeClr val="accent1"/>
+          </a:fillRef>
+          <a:effectRef idx="0">
+            <a:schemeClr val="accent1"/>
+          </a:effectRef>
+          <a:fontRef idx="minor">
+            <a:schemeClr val="lt1"/>
+          </a:fontRef>
+        </p:style>
+        <p:txBody>
+          <a:bodyPr rtlCol="0" anchor="ctr"/>
+          <a:lstStyle/>
+          <a:p>
+            <a:pPr algn="ctr"/>
+            <a:endParaRPr lang="en-US"/>
+          </a:p>
+        </p:txBody>
+      </p:sp>
+      <p:sp>
+        <p:nvSpPr>
+          <p:cNvPr id="68" name="Freeform 67">
+            <a:extLst>
+              <a:ext uri="{FF2B5EF4-FFF2-40B4-BE49-F238E27FC236}">
+                <a16:creationId xmlns:a16="http://schemas.microsoft.com/office/drawing/2014/main" id="{F5876390-55A4-1449-8629-547457430187}"/>
+              </a:ext>
+            </a:extLst>
+          </p:cNvPr>
+          <p:cNvSpPr/>
+          <p:nvPr/>
+        </p:nvSpPr>
+        <p:spPr>
+          <a:xfrm>
+            <a:off x="6203950" y="3403600"/>
+            <a:ext cx="149225" cy="184150"/>
+          </a:xfrm>
+          <a:custGeom>
+            <a:avLst/>
+            <a:gdLst>
+              <a:gd name="connsiteX0" fmla="*/ 149225 w 149225"/>
+              <a:gd name="connsiteY0" fmla="*/ 146050 h 184150"/>
+              <a:gd name="connsiteX1" fmla="*/ 53975 w 149225"/>
+              <a:gd name="connsiteY1" fmla="*/ 0 h 184150"/>
+              <a:gd name="connsiteX2" fmla="*/ 15875 w 149225"/>
+              <a:gd name="connsiteY2" fmla="*/ 38100 h 184150"/>
+              <a:gd name="connsiteX3" fmla="*/ 0 w 149225"/>
+              <a:gd name="connsiteY3" fmla="*/ 88900 h 184150"/>
+              <a:gd name="connsiteX4" fmla="*/ 3175 w 149225"/>
+              <a:gd name="connsiteY4" fmla="*/ 127000 h 184150"/>
+              <a:gd name="connsiteX5" fmla="*/ 12700 w 149225"/>
+              <a:gd name="connsiteY5" fmla="*/ 155575 h 184150"/>
+              <a:gd name="connsiteX6" fmla="*/ 31750 w 149225"/>
+              <a:gd name="connsiteY6" fmla="*/ 184150 h 184150"/>
+              <a:gd name="connsiteX7" fmla="*/ 149225 w 149225"/>
+              <a:gd name="connsiteY7" fmla="*/ 146050 h 184150"/>
+            </a:gdLst>
+            <a:ahLst/>
+            <a:cxnLst>
+              <a:cxn ang="0">
+                <a:pos x="connsiteX0" y="connsiteY0"/>
+              </a:cxn>
+              <a:cxn ang="0">
+                <a:pos x="connsiteX1" y="connsiteY1"/>
+              </a:cxn>
+              <a:cxn ang="0">
+                <a:pos x="connsiteX2" y="connsiteY2"/>
+              </a:cxn>
+              <a:cxn ang="0">
+                <a:pos x="connsiteX3" y="connsiteY3"/>
+              </a:cxn>
+              <a:cxn ang="0">
+                <a:pos x="connsiteX4" y="connsiteY4"/>
+              </a:cxn>
+              <a:cxn ang="0">
+                <a:pos x="connsiteX5" y="connsiteY5"/>
+              </a:cxn>
+              <a:cxn ang="0">
+                <a:pos x="connsiteX6" y="connsiteY6"/>
+              </a:cxn>
+              <a:cxn ang="0">
+                <a:pos x="connsiteX7" y="connsiteY7"/>
+              </a:cxn>
+            </a:cxnLst>
+            <a:rect l="l" t="t" r="r" b="b"/>
+            <a:pathLst>
+              <a:path w="149225" h="184150">
+                <a:moveTo>
+                  <a:pt x="149225" y="146050"/>
+                </a:moveTo>
+                <a:lnTo>
+                  <a:pt x="53975" y="0"/>
+                </a:lnTo>
+                <a:lnTo>
+                  <a:pt x="15875" y="38100"/>
+                </a:lnTo>
+                <a:lnTo>
+                  <a:pt x="0" y="88900"/>
+                </a:lnTo>
+                <a:lnTo>
+                  <a:pt x="3175" y="127000"/>
+                </a:lnTo>
+                <a:lnTo>
+                  <a:pt x="12700" y="155575"/>
+                </a:lnTo>
+                <a:lnTo>
+                  <a:pt x="31750" y="184150"/>
+                </a:lnTo>
+                <a:lnTo>
+                  <a:pt x="149225" y="146050"/>
+                </a:lnTo>
+                <a:close/>
+              </a:path>
+            </a:pathLst>
+          </a:custGeom>
+          <a:solidFill>
+            <a:srgbClr val="00B0F0"/>
+          </a:solidFill>
+        </p:spPr>
+        <p:style>
+          <a:lnRef idx="2">
+            <a:schemeClr val="accent1">
+              <a:shade val="50000"/>
+            </a:schemeClr>
+          </a:lnRef>
+          <a:fillRef idx="1">
+            <a:schemeClr val="accent1"/>
+          </a:fillRef>
+          <a:effectRef idx="0">
+            <a:schemeClr val="accent1"/>
+          </a:effectRef>
+          <a:fontRef idx="minor">
+            <a:schemeClr val="lt1"/>
+          </a:fontRef>
+        </p:style>
+        <p:txBody>
+          <a:bodyPr rtlCol="0" anchor="ctr"/>
+          <a:lstStyle/>
+          <a:p>
+            <a:pPr algn="ctr"/>
+            <a:endParaRPr lang="en-US"/>
+          </a:p>
+        </p:txBody>
+      </p:sp>
+      <p:sp>
+        <p:nvSpPr>
+          <p:cNvPr id="69" name="Chord 68">
+            <a:extLst>
+              <a:ext uri="{FF2B5EF4-FFF2-40B4-BE49-F238E27FC236}">
+                <a16:creationId xmlns:a16="http://schemas.microsoft.com/office/drawing/2014/main" id="{B5F9798C-B098-BE40-A567-1A9047E0CEB2}"/>
+              </a:ext>
+            </a:extLst>
+          </p:cNvPr>
+          <p:cNvSpPr/>
+          <p:nvPr/>
+        </p:nvSpPr>
+        <p:spPr>
+          <a:xfrm rot="20700000">
+            <a:off x="5620377" y="2677311"/>
+            <a:ext cx="255722" cy="286719"/>
+          </a:xfrm>
+          <a:prstGeom prst="chord">
+            <a:avLst/>
+          </a:prstGeom>
+          <a:solidFill>
+            <a:srgbClr val="00B0F0"/>
+          </a:solidFill>
+        </p:spPr>
+        <p:style>
+          <a:lnRef idx="2">
+            <a:schemeClr val="accent1">
+              <a:shade val="50000"/>
+            </a:schemeClr>
+          </a:lnRef>
+          <a:fillRef idx="1">
+            <a:schemeClr val="accent1"/>
+          </a:fillRef>
+          <a:effectRef idx="0">
+            <a:schemeClr val="accent1"/>
+          </a:effectRef>
+          <a:fontRef idx="minor">
+            <a:schemeClr val="lt1"/>
+          </a:fontRef>
+        </p:style>
+        <p:txBody>
+          <a:bodyPr rtlCol="0" anchor="ctr"/>
+          <a:lstStyle/>
+          <a:p>
+            <a:pPr algn="ctr"/>
+            <a:endParaRPr lang="en-US"/>
+          </a:p>
+        </p:txBody>
+      </p:sp>
+      <p:sp>
+        <p:nvSpPr>
+          <p:cNvPr id="70" name="Chord 69">
+            <a:extLst>
+              <a:ext uri="{FF2B5EF4-FFF2-40B4-BE49-F238E27FC236}">
+                <a16:creationId xmlns:a16="http://schemas.microsoft.com/office/drawing/2014/main" id="{5560D64B-F22A-5D4B-852A-4012A6128CE1}"/>
+              </a:ext>
+            </a:extLst>
+          </p:cNvPr>
+          <p:cNvSpPr/>
+          <p:nvPr/>
+        </p:nvSpPr>
+        <p:spPr>
+          <a:xfrm rot="20700000" flipH="1" flipV="1">
+            <a:off x="5743690" y="2597553"/>
+            <a:ext cx="255722" cy="286719"/>
+          </a:xfrm>
+          <a:prstGeom prst="chord">
+            <a:avLst/>
+          </a:prstGeom>
+          <a:solidFill>
+            <a:srgbClr val="00B050"/>
+          </a:solidFill>
+        </p:spPr>
+        <p:style>
+          <a:lnRef idx="2">
+            <a:schemeClr val="accent1">
+              <a:shade val="50000"/>
+            </a:schemeClr>
+          </a:lnRef>
+          <a:fillRef idx="1">
+            <a:schemeClr val="accent1"/>
+          </a:fillRef>
+          <a:effectRef idx="0">
+            <a:schemeClr val="accent1"/>
+          </a:effectRef>
+          <a:fontRef idx="minor">
+            <a:schemeClr val="lt1"/>
+          </a:fontRef>
+        </p:style>
+        <p:txBody>
+          <a:bodyPr rtlCol="0" anchor="ctr"/>
+          <a:lstStyle/>
+          <a:p>
+            <a:pPr algn="ctr"/>
+            <a:endParaRPr lang="en-US"/>
+          </a:p>
+        </p:txBody>
+      </p:sp>
+      <p:sp>
+        <p:nvSpPr>
+          <p:cNvPr id="71" name="Chord 70">
+            <a:extLst>
+              <a:ext uri="{FF2B5EF4-FFF2-40B4-BE49-F238E27FC236}">
+                <a16:creationId xmlns:a16="http://schemas.microsoft.com/office/drawing/2014/main" id="{AF88DCFB-99D5-E44B-9D76-9CB5593FACE9}"/>
+              </a:ext>
+            </a:extLst>
+          </p:cNvPr>
+          <p:cNvSpPr/>
+          <p:nvPr/>
+        </p:nvSpPr>
+        <p:spPr>
+          <a:xfrm rot="20700000">
+            <a:off x="4841208" y="1570107"/>
+            <a:ext cx="255722" cy="286719"/>
+          </a:xfrm>
+          <a:prstGeom prst="chord">
+            <a:avLst/>
+          </a:prstGeom>
+          <a:solidFill>
+            <a:srgbClr val="00B0F0"/>
+          </a:solidFill>
+        </p:spPr>
+        <p:style>
+          <a:lnRef idx="2">
+            <a:schemeClr val="accent1">
+              <a:shade val="50000"/>
+            </a:schemeClr>
+          </a:lnRef>
+          <a:fillRef idx="1">
+            <a:schemeClr val="accent1"/>
+          </a:fillRef>
+          <a:effectRef idx="0">
+            <a:schemeClr val="accent1"/>
+          </a:effectRef>
+          <a:fontRef idx="minor">
+            <a:schemeClr val="lt1"/>
+          </a:fontRef>
+        </p:style>
+        <p:txBody>
+          <a:bodyPr rtlCol="0" anchor="ctr"/>
+          <a:lstStyle/>
+          <a:p>
+            <a:pPr algn="ctr"/>
+            <a:endParaRPr lang="en-US"/>
+          </a:p>
+        </p:txBody>
+      </p:sp>
+      <p:sp>
+        <p:nvSpPr>
+          <p:cNvPr id="72" name="Chord 71">
+            <a:extLst>
+              <a:ext uri="{FF2B5EF4-FFF2-40B4-BE49-F238E27FC236}">
+                <a16:creationId xmlns:a16="http://schemas.microsoft.com/office/drawing/2014/main" id="{9889A818-7CD7-5440-9CE3-A69ED2D165AC}"/>
+              </a:ext>
+            </a:extLst>
+          </p:cNvPr>
+          <p:cNvSpPr/>
+          <p:nvPr/>
+        </p:nvSpPr>
+        <p:spPr>
+          <a:xfrm rot="20700000" flipH="1" flipV="1">
+            <a:off x="4925776" y="1505847"/>
+            <a:ext cx="255722" cy="286719"/>
+          </a:xfrm>
+          <a:prstGeom prst="chord">
+            <a:avLst/>
+          </a:prstGeom>
+          <a:solidFill>
+            <a:srgbClr val="00B050"/>
+          </a:solidFill>
+        </p:spPr>
+        <p:style>
+          <a:lnRef idx="2">
+            <a:schemeClr val="accent1">
+              <a:shade val="50000"/>
+            </a:schemeClr>
+          </a:lnRef>
+          <a:fillRef idx="1">
+            <a:schemeClr val="accent1"/>
+          </a:fillRef>
+          <a:effectRef idx="0">
+            <a:schemeClr val="accent1"/>
+          </a:effectRef>
+          <a:fontRef idx="minor">
+            <a:schemeClr val="lt1"/>
+          </a:fontRef>
+        </p:style>
+        <p:txBody>
+          <a:bodyPr rtlCol="0" anchor="ctr"/>
+          <a:lstStyle/>
+          <a:p>
+            <a:pPr algn="ctr"/>
+            <a:endParaRPr lang="en-US"/>
+          </a:p>
+        </p:txBody>
+      </p:sp>
+      <p:sp>
+        <p:nvSpPr>
+          <p:cNvPr id="73" name="Oval 72">
+            <a:extLst>
+              <a:ext uri="{FF2B5EF4-FFF2-40B4-BE49-F238E27FC236}">
+                <a16:creationId xmlns:a16="http://schemas.microsoft.com/office/drawing/2014/main" id="{13B557D5-C246-AB47-B459-D6F06B040036}"/>
+              </a:ext>
+            </a:extLst>
+          </p:cNvPr>
+          <p:cNvSpPr/>
+          <p:nvPr/>
+        </p:nvSpPr>
+        <p:spPr>
+          <a:xfrm>
+            <a:off x="8826285" y="2569344"/>
+            <a:ext cx="511444" cy="538733"/>
+          </a:xfrm>
+          <a:prstGeom prst="ellipse">
+            <a:avLst/>
+          </a:prstGeom>
+          <a:noFill/>
+          <a:ln w="28575">
+            <a:solidFill>
+              <a:schemeClr val="accent4">
+                <a:lumMod val="60000"/>
+                <a:lumOff val="40000"/>
+              </a:schemeClr>
+            </a:solidFill>
+          </a:ln>
+        </p:spPr>
+        <p:style>
+          <a:lnRef idx="2">
+            <a:schemeClr val="accent1">
+              <a:shade val="50000"/>
+            </a:schemeClr>
+          </a:lnRef>
+          <a:fillRef idx="1">
+            <a:schemeClr val="accent1"/>
+          </a:fillRef>
+          <a:effectRef idx="0">
+            <a:schemeClr val="accent1"/>
+          </a:effectRef>
+          <a:fontRef idx="minor">
+            <a:schemeClr val="lt1"/>
+          </a:fontRef>
+        </p:style>
+        <p:txBody>
+          <a:bodyPr rtlCol="0" anchor="ctr"/>
+          <a:lstStyle/>
+          <a:p>
+            <a:pPr algn="ctr"/>
+            <a:endParaRPr lang="en-US"/>
+          </a:p>
+        </p:txBody>
+      </p:sp>
+      <p:sp>
+        <p:nvSpPr>
+          <p:cNvPr id="74" name="Oval 73">
+            <a:extLst>
+              <a:ext uri="{FF2B5EF4-FFF2-40B4-BE49-F238E27FC236}">
+                <a16:creationId xmlns:a16="http://schemas.microsoft.com/office/drawing/2014/main" id="{E48F97F0-A6FC-414B-814B-DA44BE794C55}"/>
+              </a:ext>
+            </a:extLst>
+          </p:cNvPr>
+          <p:cNvSpPr/>
+          <p:nvPr/>
+        </p:nvSpPr>
+        <p:spPr>
+          <a:xfrm>
+            <a:off x="8160224" y="2743200"/>
+            <a:ext cx="511444" cy="605814"/>
+          </a:xfrm>
+          <a:prstGeom prst="ellipse">
+            <a:avLst/>
+          </a:prstGeom>
+          <a:noFill/>
+          <a:ln w="28575">
+            <a:solidFill>
+              <a:srgbClr val="FFC000"/>
+            </a:solidFill>
+          </a:ln>
+        </p:spPr>
+        <p:style>
+          <a:lnRef idx="2">
+            <a:schemeClr val="accent1">
+              <a:shade val="50000"/>
+            </a:schemeClr>
+          </a:lnRef>
+          <a:fillRef idx="1">
+            <a:schemeClr val="accent1"/>
+          </a:fillRef>
+          <a:effectRef idx="0">
+            <a:schemeClr val="accent1"/>
+          </a:effectRef>
+          <a:fontRef idx="minor">
+            <a:schemeClr val="lt1"/>
+          </a:fontRef>
+        </p:style>
+        <p:txBody>
+          <a:bodyPr rtlCol="0" anchor="ctr"/>
+          <a:lstStyle/>
+          <a:p>
+            <a:pPr algn="ctr"/>
+            <a:endParaRPr lang="en-US"/>
+          </a:p>
+        </p:txBody>
+      </p:sp>
+      <p:sp>
+        <p:nvSpPr>
+          <p:cNvPr id="75" name="Oval 74">
+            <a:extLst>
+              <a:ext uri="{FF2B5EF4-FFF2-40B4-BE49-F238E27FC236}">
+                <a16:creationId xmlns:a16="http://schemas.microsoft.com/office/drawing/2014/main" id="{90309A9F-03CA-BF41-AB82-1DA926671FE9}"/>
+              </a:ext>
+            </a:extLst>
+          </p:cNvPr>
+          <p:cNvSpPr/>
+          <p:nvPr/>
+        </p:nvSpPr>
+        <p:spPr>
+          <a:xfrm>
+            <a:off x="7499329" y="2914203"/>
+            <a:ext cx="511444" cy="605814"/>
+          </a:xfrm>
+          <a:prstGeom prst="ellipse">
+            <a:avLst/>
+          </a:prstGeom>
+          <a:noFill/>
+          <a:ln w="28575">
+            <a:solidFill>
+              <a:srgbClr val="FFC000"/>
+            </a:solidFill>
+          </a:ln>
+        </p:spPr>
+        <p:style>
+          <a:lnRef idx="2">
+            <a:schemeClr val="accent1">
+              <a:shade val="50000"/>
+            </a:schemeClr>
+          </a:lnRef>
+          <a:fillRef idx="1">
+            <a:schemeClr val="accent1"/>
+          </a:fillRef>
+          <a:effectRef idx="0">
+            <a:schemeClr val="accent1"/>
+          </a:effectRef>
+          <a:fontRef idx="minor">
+            <a:schemeClr val="lt1"/>
+          </a:fontRef>
+        </p:style>
+        <p:txBody>
+          <a:bodyPr rtlCol="0" anchor="ctr"/>
+          <a:lstStyle/>
+          <a:p>
+            <a:pPr algn="ctr"/>
+            <a:endParaRPr lang="en-US"/>
+          </a:p>
+        </p:txBody>
+      </p:sp>
+      <p:sp>
+        <p:nvSpPr>
+          <p:cNvPr id="76" name="Oval 75">
+            <a:extLst>
+              <a:ext uri="{FF2B5EF4-FFF2-40B4-BE49-F238E27FC236}">
+                <a16:creationId xmlns:a16="http://schemas.microsoft.com/office/drawing/2014/main" id="{32CFE2E2-5564-7C4E-9233-242165D748E7}"/>
+              </a:ext>
+            </a:extLst>
+          </p:cNvPr>
+          <p:cNvSpPr/>
+          <p:nvPr/>
+        </p:nvSpPr>
+        <p:spPr>
+          <a:xfrm>
+            <a:off x="6838434" y="3085206"/>
+            <a:ext cx="511444" cy="605814"/>
+          </a:xfrm>
+          <a:prstGeom prst="ellipse">
+            <a:avLst/>
+          </a:prstGeom>
+          <a:noFill/>
+          <a:ln w="28575">
+            <a:solidFill>
+              <a:srgbClr val="FFC000"/>
+            </a:solidFill>
+          </a:ln>
+        </p:spPr>
+        <p:style>
+          <a:lnRef idx="2">
+            <a:schemeClr val="accent1">
+              <a:shade val="50000"/>
+            </a:schemeClr>
+          </a:lnRef>
+          <a:fillRef idx="1">
+            <a:schemeClr val="accent1"/>
+          </a:fillRef>
+          <a:effectRef idx="0">
+            <a:schemeClr val="accent1"/>
+          </a:effectRef>
+          <a:fontRef idx="minor">
+            <a:schemeClr val="lt1"/>
+          </a:fontRef>
+        </p:style>
+        <p:txBody>
+          <a:bodyPr rtlCol="0" anchor="ctr"/>
+          <a:lstStyle/>
+          <a:p>
+            <a:pPr algn="ctr"/>
+            <a:endParaRPr lang="en-US"/>
+          </a:p>
+        </p:txBody>
+      </p:sp>
+      <p:sp>
+        <p:nvSpPr>
+          <p:cNvPr id="77" name="Oval 76">
+            <a:extLst>
+              <a:ext uri="{FF2B5EF4-FFF2-40B4-BE49-F238E27FC236}">
+                <a16:creationId xmlns:a16="http://schemas.microsoft.com/office/drawing/2014/main" id="{DF2BE6A4-5FE1-094F-9040-C124CD785662}"/>
+              </a:ext>
+            </a:extLst>
+          </p:cNvPr>
+          <p:cNvSpPr/>
+          <p:nvPr/>
+        </p:nvSpPr>
+        <p:spPr>
+          <a:xfrm>
+            <a:off x="6131045" y="3256209"/>
+            <a:ext cx="511444" cy="605814"/>
+          </a:xfrm>
+          <a:prstGeom prst="ellipse">
+            <a:avLst/>
+          </a:prstGeom>
+          <a:noFill/>
+          <a:ln w="28575">
+            <a:solidFill>
+              <a:srgbClr val="FF0000"/>
+            </a:solidFill>
+          </a:ln>
+        </p:spPr>
+        <p:style>
+          <a:lnRef idx="2">
+            <a:schemeClr val="accent1">
+              <a:shade val="50000"/>
+            </a:schemeClr>
+          </a:lnRef>
+          <a:fillRef idx="1">
+            <a:schemeClr val="accent1"/>
+          </a:fillRef>
+          <a:effectRef idx="0">
+            <a:schemeClr val="accent1"/>
+          </a:effectRef>
+          <a:fontRef idx="minor">
+            <a:schemeClr val="lt1"/>
+          </a:fontRef>
+        </p:style>
+        <p:txBody>
+          <a:bodyPr rtlCol="0" anchor="ctr"/>
+          <a:lstStyle/>
+          <a:p>
+            <a:pPr algn="ctr"/>
+            <a:endParaRPr lang="en-US"/>
+          </a:p>
+        </p:txBody>
+      </p:sp>
+      <p:sp>
+        <p:nvSpPr>
+          <p:cNvPr id="78" name="Oval 77">
+            <a:extLst>
+              <a:ext uri="{FF2B5EF4-FFF2-40B4-BE49-F238E27FC236}">
+                <a16:creationId xmlns:a16="http://schemas.microsoft.com/office/drawing/2014/main" id="{A480620A-A7C3-6E49-9CEA-38EB35825D35}"/>
+              </a:ext>
+            </a:extLst>
+          </p:cNvPr>
+          <p:cNvSpPr/>
+          <p:nvPr/>
+        </p:nvSpPr>
+        <p:spPr>
+          <a:xfrm>
+            <a:off x="5446903" y="3458208"/>
+            <a:ext cx="511444" cy="605814"/>
+          </a:xfrm>
+          <a:prstGeom prst="ellipse">
+            <a:avLst/>
+          </a:prstGeom>
+          <a:noFill/>
+          <a:ln w="28575">
+            <a:solidFill>
+              <a:srgbClr val="FFC000"/>
+            </a:solidFill>
+          </a:ln>
+        </p:spPr>
+        <p:style>
+          <a:lnRef idx="2">
+            <a:schemeClr val="accent1">
+              <a:shade val="50000"/>
+            </a:schemeClr>
+          </a:lnRef>
+          <a:fillRef idx="1">
+            <a:schemeClr val="accent1"/>
+          </a:fillRef>
+          <a:effectRef idx="0">
+            <a:schemeClr val="accent1"/>
+          </a:effectRef>
+          <a:fontRef idx="minor">
+            <a:schemeClr val="lt1"/>
+          </a:fontRef>
+        </p:style>
+        <p:txBody>
+          <a:bodyPr rtlCol="0" anchor="ctr"/>
+          <a:lstStyle/>
+          <a:p>
+            <a:pPr algn="ctr"/>
+            <a:endParaRPr lang="en-US"/>
+          </a:p>
+        </p:txBody>
+      </p:sp>
+      <p:sp>
+        <p:nvSpPr>
+          <p:cNvPr id="79" name="Oval 78">
+            <a:extLst>
+              <a:ext uri="{FF2B5EF4-FFF2-40B4-BE49-F238E27FC236}">
+                <a16:creationId xmlns:a16="http://schemas.microsoft.com/office/drawing/2014/main" id="{363B6E70-E008-9141-8A80-8076361BD290}"/>
+              </a:ext>
+            </a:extLst>
+          </p:cNvPr>
+          <p:cNvSpPr/>
+          <p:nvPr/>
+        </p:nvSpPr>
+        <p:spPr>
+          <a:xfrm>
+            <a:off x="4762761" y="3636960"/>
+            <a:ext cx="511444" cy="605814"/>
+          </a:xfrm>
+          <a:prstGeom prst="ellipse">
+            <a:avLst/>
+          </a:prstGeom>
+          <a:noFill/>
+          <a:ln w="28575">
+            <a:solidFill>
+              <a:srgbClr val="FFC000"/>
+            </a:solidFill>
+          </a:ln>
+        </p:spPr>
+        <p:style>
+          <a:lnRef idx="2">
+            <a:schemeClr val="accent1">
+              <a:shade val="50000"/>
+            </a:schemeClr>
+          </a:lnRef>
+          <a:fillRef idx="1">
+            <a:schemeClr val="accent1"/>
+          </a:fillRef>
+          <a:effectRef idx="0">
+            <a:schemeClr val="accent1"/>
+          </a:effectRef>
+          <a:fontRef idx="minor">
+            <a:schemeClr val="lt1"/>
+          </a:fontRef>
+        </p:style>
+        <p:txBody>
+          <a:bodyPr rtlCol="0" anchor="ctr"/>
+          <a:lstStyle/>
+          <a:p>
+            <a:pPr algn="ctr"/>
+            <a:endParaRPr lang="en-US"/>
+          </a:p>
+        </p:txBody>
+      </p:sp>
+      <p:sp>
+        <p:nvSpPr>
+          <p:cNvPr id="80" name="Oval 79">
+            <a:extLst>
+              <a:ext uri="{FF2B5EF4-FFF2-40B4-BE49-F238E27FC236}">
+                <a16:creationId xmlns:a16="http://schemas.microsoft.com/office/drawing/2014/main" id="{AFA0A586-391F-0D4A-8887-328F5FB11E40}"/>
+              </a:ext>
+            </a:extLst>
+          </p:cNvPr>
+          <p:cNvSpPr/>
+          <p:nvPr/>
+        </p:nvSpPr>
+        <p:spPr>
+          <a:xfrm>
+            <a:off x="4101866" y="3831210"/>
+            <a:ext cx="511444" cy="605814"/>
+          </a:xfrm>
+          <a:prstGeom prst="ellipse">
+            <a:avLst/>
+          </a:prstGeom>
+          <a:noFill/>
+          <a:ln w="28575">
+            <a:solidFill>
+              <a:srgbClr val="FFC000"/>
+            </a:solidFill>
+          </a:ln>
+        </p:spPr>
+        <p:style>
+          <a:lnRef idx="2">
+            <a:schemeClr val="accent1">
+              <a:shade val="50000"/>
+            </a:schemeClr>
+          </a:lnRef>
+          <a:fillRef idx="1">
+            <a:schemeClr val="accent1"/>
+          </a:fillRef>
+          <a:effectRef idx="0">
+            <a:schemeClr val="accent1"/>
+          </a:effectRef>
+          <a:fontRef idx="minor">
+            <a:schemeClr val="lt1"/>
+          </a:fontRef>
+        </p:style>
+        <p:txBody>
+          <a:bodyPr rtlCol="0" anchor="ctr"/>
+          <a:lstStyle/>
+          <a:p>
+            <a:pPr algn="ctr"/>
+            <a:endParaRPr lang="en-US"/>
+          </a:p>
+        </p:txBody>
+      </p:sp>
+      <p:sp>
+        <p:nvSpPr>
+          <p:cNvPr id="81" name="Oval 80">
+            <a:extLst>
+              <a:ext uri="{FF2B5EF4-FFF2-40B4-BE49-F238E27FC236}">
+                <a16:creationId xmlns:a16="http://schemas.microsoft.com/office/drawing/2014/main" id="{B6DA81E9-3BF8-F741-A5B9-4A43BC23F9F9}"/>
+              </a:ext>
+            </a:extLst>
+          </p:cNvPr>
+          <p:cNvSpPr/>
+          <p:nvPr/>
+        </p:nvSpPr>
+        <p:spPr>
+          <a:xfrm>
+            <a:off x="3425473" y="4064022"/>
+            <a:ext cx="511444" cy="507978"/>
+          </a:xfrm>
+          <a:prstGeom prst="ellipse">
+            <a:avLst/>
+          </a:prstGeom>
+          <a:noFill/>
+          <a:ln w="28575">
+            <a:solidFill>
+              <a:schemeClr val="accent4">
+                <a:lumMod val="60000"/>
+                <a:lumOff val="40000"/>
+              </a:schemeClr>
+            </a:solidFill>
+          </a:ln>
+        </p:spPr>
+        <p:style>
+          <a:lnRef idx="2">
+            <a:schemeClr val="accent1">
+              <a:shade val="50000"/>
+            </a:schemeClr>
+          </a:lnRef>
+          <a:fillRef idx="1">
+            <a:schemeClr val="accent1"/>
+          </a:fillRef>
+          <a:effectRef idx="0">
+            <a:schemeClr val="accent1"/>
+          </a:effectRef>
+          <a:fontRef idx="minor">
+            <a:schemeClr val="lt1"/>
+          </a:fontRef>
+        </p:style>
+        <p:txBody>
+          <a:bodyPr rtlCol="0" anchor="ctr"/>
+          <a:lstStyle/>
+          <a:p>
+            <a:pPr algn="ctr"/>
+            <a:endParaRPr lang="en-US"/>
+          </a:p>
+        </p:txBody>
+      </p:sp>
+      <p:sp>
+        <p:nvSpPr>
+          <p:cNvPr id="82" name="Oval 81">
+            <a:extLst>
+              <a:ext uri="{FF2B5EF4-FFF2-40B4-BE49-F238E27FC236}">
+                <a16:creationId xmlns:a16="http://schemas.microsoft.com/office/drawing/2014/main" id="{4A6DF630-BFC5-304D-A75C-6EEF1E012538}"/>
+              </a:ext>
+            </a:extLst>
+          </p:cNvPr>
+          <p:cNvSpPr/>
+          <p:nvPr/>
+        </p:nvSpPr>
+        <p:spPr>
+          <a:xfrm>
+            <a:off x="5512330" y="2522849"/>
+            <a:ext cx="593269" cy="504367"/>
+          </a:xfrm>
+          <a:prstGeom prst="ellipse">
+            <a:avLst/>
+          </a:prstGeom>
+          <a:noFill/>
+          <a:ln w="28575">
+            <a:solidFill>
+              <a:srgbClr val="FFC000"/>
+            </a:solidFill>
+          </a:ln>
+        </p:spPr>
+        <p:style>
+          <a:lnRef idx="2">
+            <a:schemeClr val="accent1">
+              <a:shade val="50000"/>
+            </a:schemeClr>
+          </a:lnRef>
+          <a:fillRef idx="1">
+            <a:schemeClr val="accent1"/>
+          </a:fillRef>
+          <a:effectRef idx="0">
+            <a:schemeClr val="accent1"/>
+          </a:effectRef>
+          <a:fontRef idx="minor">
+            <a:schemeClr val="lt1"/>
+          </a:fontRef>
+        </p:style>
+        <p:txBody>
+          <a:bodyPr rtlCol="0" anchor="ctr"/>
+          <a:lstStyle/>
+          <a:p>
+            <a:pPr algn="ctr"/>
+            <a:endParaRPr lang="en-US"/>
+          </a:p>
+        </p:txBody>
+      </p:sp>
+      <p:sp>
+        <p:nvSpPr>
+          <p:cNvPr id="83" name="Oval 82">
+            <a:extLst>
+              <a:ext uri="{FF2B5EF4-FFF2-40B4-BE49-F238E27FC236}">
+                <a16:creationId xmlns:a16="http://schemas.microsoft.com/office/drawing/2014/main" id="{C0A8BBB4-E6E5-0442-90DC-2A4DF5C08B7E}"/>
+              </a:ext>
+            </a:extLst>
+          </p:cNvPr>
+          <p:cNvSpPr/>
+          <p:nvPr/>
+        </p:nvSpPr>
+        <p:spPr>
+          <a:xfrm>
+            <a:off x="4721848" y="1443428"/>
+            <a:ext cx="593269" cy="504367"/>
+          </a:xfrm>
+          <a:prstGeom prst="ellipse">
+            <a:avLst/>
+          </a:prstGeom>
+          <a:noFill/>
+          <a:ln w="28575">
+            <a:solidFill>
+              <a:srgbClr val="FFC000"/>
+            </a:solidFill>
+          </a:ln>
+        </p:spPr>
+        <p:style>
+          <a:lnRef idx="2">
+            <a:schemeClr val="accent1">
+              <a:shade val="50000"/>
+            </a:schemeClr>
+          </a:lnRef>
+          <a:fillRef idx="1">
+            <a:schemeClr val="accent1"/>
+          </a:fillRef>
+          <a:effectRef idx="0">
+            <a:schemeClr val="accent1"/>
+          </a:effectRef>
+          <a:fontRef idx="minor">
+            <a:schemeClr val="lt1"/>
+          </a:fontRef>
+        </p:style>
+        <p:txBody>
+          <a:bodyPr rtlCol="0" anchor="ctr"/>
+          <a:lstStyle/>
+          <a:p>
+            <a:pPr algn="ctr"/>
+            <a:endParaRPr lang="en-US"/>
+          </a:p>
+        </p:txBody>
+      </p:sp>
+      <p:sp>
+        <p:nvSpPr>
+          <p:cNvPr id="84" name="TextBox 83">
+            <a:extLst>
+              <a:ext uri="{FF2B5EF4-FFF2-40B4-BE49-F238E27FC236}">
+                <a16:creationId xmlns:a16="http://schemas.microsoft.com/office/drawing/2014/main" id="{44CF4E5F-F813-BB49-B2E9-B1CF56CFB988}"/>
+              </a:ext>
+            </a:extLst>
+          </p:cNvPr>
+          <p:cNvSpPr txBox="1"/>
+          <p:nvPr/>
+        </p:nvSpPr>
+        <p:spPr>
+          <a:xfrm>
+            <a:off x="3544472" y="4506447"/>
+            <a:ext cx="327334" cy="400110"/>
+          </a:xfrm>
+          <a:prstGeom prst="rect">
+            <a:avLst/>
+          </a:prstGeom>
+          <a:noFill/>
+        </p:spPr>
+        <p:txBody>
+          <a:bodyPr wrap="none" rtlCol="0">
+            <a:spAutoFit/>
+          </a:bodyPr>
+          <a:lstStyle/>
+          <a:p>
+            <a:r>
+              <a:rPr lang="en-US" sz="2000" dirty="0">
+                <a:latin typeface="Arial" panose="020B0604020202020204" pitchFamily="34" charset="0"/>
+                <a:cs typeface="Arial" panose="020B0604020202020204" pitchFamily="34" charset="0"/>
+              </a:rPr>
+              <a:t>1</a:t>
+            </a:r>
+          </a:p>
+        </p:txBody>
+      </p:sp>
+      <p:sp>
+        <p:nvSpPr>
+          <p:cNvPr id="85" name="TextBox 84">
+            <a:extLst>
+              <a:ext uri="{FF2B5EF4-FFF2-40B4-BE49-F238E27FC236}">
+                <a16:creationId xmlns:a16="http://schemas.microsoft.com/office/drawing/2014/main" id="{E9E2E632-532A-E345-99F5-0DE08447CEB4}"/>
+              </a:ext>
+            </a:extLst>
+          </p:cNvPr>
+          <p:cNvSpPr txBox="1"/>
+          <p:nvPr/>
+        </p:nvSpPr>
+        <p:spPr>
+          <a:xfrm>
+            <a:off x="4511263" y="4194993"/>
+            <a:ext cx="327334" cy="400110"/>
+          </a:xfrm>
+          <a:prstGeom prst="rect">
+            <a:avLst/>
+          </a:prstGeom>
+          <a:noFill/>
+        </p:spPr>
+        <p:txBody>
+          <a:bodyPr wrap="none" rtlCol="0">
+            <a:spAutoFit/>
+          </a:bodyPr>
+          <a:lstStyle/>
+          <a:p>
+            <a:r>
+              <a:rPr lang="en-US" sz="2000" dirty="0">
+                <a:latin typeface="Arial" panose="020B0604020202020204" pitchFamily="34" charset="0"/>
+                <a:cs typeface="Arial" panose="020B0604020202020204" pitchFamily="34" charset="0"/>
+              </a:rPr>
+              <a:t>2</a:t>
+            </a:r>
+          </a:p>
+        </p:txBody>
+      </p:sp>
+      <p:sp>
+        <p:nvSpPr>
+          <p:cNvPr id="86" name="TextBox 85">
+            <a:extLst>
+              <a:ext uri="{FF2B5EF4-FFF2-40B4-BE49-F238E27FC236}">
+                <a16:creationId xmlns:a16="http://schemas.microsoft.com/office/drawing/2014/main" id="{58054A77-FACB-8249-A510-3813F52FAB0F}"/>
+              </a:ext>
+            </a:extLst>
+          </p:cNvPr>
+          <p:cNvSpPr txBox="1"/>
+          <p:nvPr/>
+        </p:nvSpPr>
+        <p:spPr>
+          <a:xfrm>
+            <a:off x="4949757" y="4161092"/>
+            <a:ext cx="327334" cy="400110"/>
+          </a:xfrm>
+          <a:prstGeom prst="rect">
+            <a:avLst/>
+          </a:prstGeom>
+          <a:noFill/>
+        </p:spPr>
+        <p:txBody>
+          <a:bodyPr wrap="none" rtlCol="0">
+            <a:spAutoFit/>
+          </a:bodyPr>
+          <a:lstStyle/>
+          <a:p>
+            <a:r>
+              <a:rPr lang="en-US" sz="2000" dirty="0">
+                <a:latin typeface="Arial" panose="020B0604020202020204" pitchFamily="34" charset="0"/>
+                <a:cs typeface="Arial" panose="020B0604020202020204" pitchFamily="34" charset="0"/>
+              </a:rPr>
+              <a:t>2</a:t>
+            </a:r>
+          </a:p>
+        </p:txBody>
+      </p:sp>
+      <p:sp>
+        <p:nvSpPr>
+          <p:cNvPr id="87" name="TextBox 86">
+            <a:extLst>
+              <a:ext uri="{FF2B5EF4-FFF2-40B4-BE49-F238E27FC236}">
+                <a16:creationId xmlns:a16="http://schemas.microsoft.com/office/drawing/2014/main" id="{F6BDD073-FEEF-2845-AB56-669C2B880E5D}"/>
+              </a:ext>
+            </a:extLst>
+          </p:cNvPr>
+          <p:cNvSpPr txBox="1"/>
+          <p:nvPr/>
+        </p:nvSpPr>
+        <p:spPr>
+          <a:xfrm>
+            <a:off x="5645297" y="3995416"/>
+            <a:ext cx="327334" cy="400110"/>
+          </a:xfrm>
+          <a:prstGeom prst="rect">
+            <a:avLst/>
+          </a:prstGeom>
+          <a:noFill/>
+        </p:spPr>
+        <p:txBody>
+          <a:bodyPr wrap="none" rtlCol="0">
+            <a:spAutoFit/>
+          </a:bodyPr>
+          <a:lstStyle/>
+          <a:p>
+            <a:r>
+              <a:rPr lang="en-US" sz="2000" dirty="0">
+                <a:latin typeface="Arial" panose="020B0604020202020204" pitchFamily="34" charset="0"/>
+                <a:cs typeface="Arial" panose="020B0604020202020204" pitchFamily="34" charset="0"/>
+              </a:rPr>
+              <a:t>2</a:t>
+            </a:r>
+          </a:p>
+        </p:txBody>
+      </p:sp>
+      <p:sp>
+        <p:nvSpPr>
+          <p:cNvPr id="88" name="TextBox 87">
+            <a:extLst>
+              <a:ext uri="{FF2B5EF4-FFF2-40B4-BE49-F238E27FC236}">
+                <a16:creationId xmlns:a16="http://schemas.microsoft.com/office/drawing/2014/main" id="{DC32A14F-AD84-514A-8448-217EAC22BB79}"/>
+              </a:ext>
+            </a:extLst>
+          </p:cNvPr>
+          <p:cNvSpPr txBox="1"/>
+          <p:nvPr/>
+        </p:nvSpPr>
+        <p:spPr>
+          <a:xfrm>
+            <a:off x="6486430" y="3703130"/>
+            <a:ext cx="327334" cy="400110"/>
+          </a:xfrm>
+          <a:prstGeom prst="rect">
+            <a:avLst/>
+          </a:prstGeom>
+          <a:noFill/>
+        </p:spPr>
+        <p:txBody>
+          <a:bodyPr wrap="none" rtlCol="0">
+            <a:spAutoFit/>
+          </a:bodyPr>
+          <a:lstStyle/>
+          <a:p>
+            <a:r>
+              <a:rPr lang="en-US" sz="2000" dirty="0">
+                <a:latin typeface="Arial" panose="020B0604020202020204" pitchFamily="34" charset="0"/>
+                <a:cs typeface="Arial" panose="020B0604020202020204" pitchFamily="34" charset="0"/>
+              </a:rPr>
+              <a:t>3</a:t>
+            </a:r>
+          </a:p>
+        </p:txBody>
+      </p:sp>
+      <p:sp>
+        <p:nvSpPr>
+          <p:cNvPr id="89" name="TextBox 88">
+            <a:extLst>
+              <a:ext uri="{FF2B5EF4-FFF2-40B4-BE49-F238E27FC236}">
+                <a16:creationId xmlns:a16="http://schemas.microsoft.com/office/drawing/2014/main" id="{2B2F25CD-2ADF-2C45-9BAE-62652C0D2ADE}"/>
+              </a:ext>
+            </a:extLst>
+          </p:cNvPr>
+          <p:cNvSpPr txBox="1"/>
+          <p:nvPr/>
+        </p:nvSpPr>
+        <p:spPr>
+          <a:xfrm>
+            <a:off x="6987164" y="3635211"/>
+            <a:ext cx="327334" cy="400110"/>
+          </a:xfrm>
+          <a:prstGeom prst="rect">
+            <a:avLst/>
+          </a:prstGeom>
+          <a:noFill/>
+        </p:spPr>
+        <p:txBody>
+          <a:bodyPr wrap="none" rtlCol="0">
+            <a:spAutoFit/>
+          </a:bodyPr>
+          <a:lstStyle/>
+          <a:p>
+            <a:r>
+              <a:rPr lang="en-US" sz="2000" dirty="0">
+                <a:latin typeface="Arial" panose="020B0604020202020204" pitchFamily="34" charset="0"/>
+                <a:cs typeface="Arial" panose="020B0604020202020204" pitchFamily="34" charset="0"/>
+              </a:rPr>
+              <a:t>2</a:t>
+            </a:r>
+          </a:p>
+        </p:txBody>
+      </p:sp>
+      <p:sp>
+        <p:nvSpPr>
+          <p:cNvPr id="90" name="TextBox 89">
+            <a:extLst>
+              <a:ext uri="{FF2B5EF4-FFF2-40B4-BE49-F238E27FC236}">
+                <a16:creationId xmlns:a16="http://schemas.microsoft.com/office/drawing/2014/main" id="{E994122E-DFB7-D84A-8594-1A4EDDA43161}"/>
+              </a:ext>
+            </a:extLst>
+          </p:cNvPr>
+          <p:cNvSpPr txBox="1"/>
+          <p:nvPr/>
+        </p:nvSpPr>
+        <p:spPr>
+          <a:xfrm>
+            <a:off x="7650539" y="3458208"/>
+            <a:ext cx="327334" cy="400110"/>
+          </a:xfrm>
+          <a:prstGeom prst="rect">
+            <a:avLst/>
+          </a:prstGeom>
+          <a:noFill/>
+        </p:spPr>
+        <p:txBody>
+          <a:bodyPr wrap="none" rtlCol="0">
+            <a:spAutoFit/>
+          </a:bodyPr>
+          <a:lstStyle/>
+          <a:p>
+            <a:r>
+              <a:rPr lang="en-US" sz="2000" dirty="0">
+                <a:latin typeface="Arial" panose="020B0604020202020204" pitchFamily="34" charset="0"/>
+                <a:cs typeface="Arial" panose="020B0604020202020204" pitchFamily="34" charset="0"/>
+              </a:rPr>
+              <a:t>2</a:t>
+            </a:r>
+          </a:p>
+        </p:txBody>
+      </p:sp>
+      <p:sp>
+        <p:nvSpPr>
+          <p:cNvPr id="91" name="TextBox 90">
+            <a:extLst>
+              <a:ext uri="{FF2B5EF4-FFF2-40B4-BE49-F238E27FC236}">
+                <a16:creationId xmlns:a16="http://schemas.microsoft.com/office/drawing/2014/main" id="{82C5582F-9F7C-1A47-9363-5867C8B81AC5}"/>
+              </a:ext>
+            </a:extLst>
+          </p:cNvPr>
+          <p:cNvSpPr txBox="1"/>
+          <p:nvPr/>
+        </p:nvSpPr>
+        <p:spPr>
+          <a:xfrm>
+            <a:off x="8313914" y="3281205"/>
+            <a:ext cx="327334" cy="400110"/>
+          </a:xfrm>
+          <a:prstGeom prst="rect">
+            <a:avLst/>
+          </a:prstGeom>
+          <a:noFill/>
+        </p:spPr>
+        <p:txBody>
+          <a:bodyPr wrap="none" rtlCol="0">
+            <a:spAutoFit/>
+          </a:bodyPr>
+          <a:lstStyle/>
+          <a:p>
+            <a:r>
+              <a:rPr lang="en-US" sz="2000" dirty="0">
+                <a:latin typeface="Arial" panose="020B0604020202020204" pitchFamily="34" charset="0"/>
+                <a:cs typeface="Arial" panose="020B0604020202020204" pitchFamily="34" charset="0"/>
+              </a:rPr>
+              <a:t>2</a:t>
+            </a:r>
+          </a:p>
+        </p:txBody>
+      </p:sp>
+      <p:sp>
+        <p:nvSpPr>
+          <p:cNvPr id="92" name="TextBox 91">
+            <a:extLst>
+              <a:ext uri="{FF2B5EF4-FFF2-40B4-BE49-F238E27FC236}">
+                <a16:creationId xmlns:a16="http://schemas.microsoft.com/office/drawing/2014/main" id="{CC67A644-B237-9A47-BB2A-3E0C7137D4B1}"/>
+              </a:ext>
+            </a:extLst>
+          </p:cNvPr>
+          <p:cNvSpPr txBox="1"/>
+          <p:nvPr/>
+        </p:nvSpPr>
+        <p:spPr>
+          <a:xfrm>
+            <a:off x="9297684" y="2638655"/>
+            <a:ext cx="327334" cy="400110"/>
+          </a:xfrm>
+          <a:prstGeom prst="rect">
+            <a:avLst/>
+          </a:prstGeom>
+          <a:noFill/>
+        </p:spPr>
+        <p:txBody>
+          <a:bodyPr wrap="none" rtlCol="0">
+            <a:spAutoFit/>
+          </a:bodyPr>
+          <a:lstStyle/>
+          <a:p>
+            <a:r>
+              <a:rPr lang="en-US" sz="2000" dirty="0">
+                <a:latin typeface="Arial" panose="020B0604020202020204" pitchFamily="34" charset="0"/>
+                <a:cs typeface="Arial" panose="020B0604020202020204" pitchFamily="34" charset="0"/>
+              </a:rPr>
+              <a:t>1</a:t>
+            </a:r>
+          </a:p>
+        </p:txBody>
+      </p:sp>
+      <p:sp>
+        <p:nvSpPr>
+          <p:cNvPr id="93" name="TextBox 92">
+            <a:extLst>
+              <a:ext uri="{FF2B5EF4-FFF2-40B4-BE49-F238E27FC236}">
+                <a16:creationId xmlns:a16="http://schemas.microsoft.com/office/drawing/2014/main" id="{E9AFACC5-DCF9-6D4A-8DB1-15E09DEEB204}"/>
+              </a:ext>
+            </a:extLst>
+          </p:cNvPr>
+          <p:cNvSpPr txBox="1"/>
+          <p:nvPr/>
+        </p:nvSpPr>
+        <p:spPr>
+          <a:xfrm>
+            <a:off x="6022104" y="2345463"/>
+            <a:ext cx="327334" cy="400110"/>
+          </a:xfrm>
+          <a:prstGeom prst="rect">
+            <a:avLst/>
+          </a:prstGeom>
+          <a:noFill/>
+        </p:spPr>
+        <p:txBody>
+          <a:bodyPr wrap="none" rtlCol="0">
+            <a:spAutoFit/>
+          </a:bodyPr>
+          <a:lstStyle/>
+          <a:p>
+            <a:r>
+              <a:rPr lang="en-US" sz="2000" dirty="0">
+                <a:latin typeface="Arial" panose="020B0604020202020204" pitchFamily="34" charset="0"/>
+                <a:cs typeface="Arial" panose="020B0604020202020204" pitchFamily="34" charset="0"/>
+              </a:rPr>
+              <a:t>2</a:t>
+            </a:r>
+          </a:p>
+        </p:txBody>
+      </p:sp>
+      <p:sp>
+        <p:nvSpPr>
+          <p:cNvPr id="94" name="TextBox 93">
+            <a:extLst>
+              <a:ext uri="{FF2B5EF4-FFF2-40B4-BE49-F238E27FC236}">
+                <a16:creationId xmlns:a16="http://schemas.microsoft.com/office/drawing/2014/main" id="{FD728C9B-0925-1C4D-8085-020CF3C7273F}"/>
+              </a:ext>
+            </a:extLst>
+          </p:cNvPr>
+          <p:cNvSpPr txBox="1"/>
+          <p:nvPr/>
+        </p:nvSpPr>
+        <p:spPr>
+          <a:xfrm>
+            <a:off x="5263572" y="1290568"/>
+            <a:ext cx="327334" cy="400110"/>
+          </a:xfrm>
+          <a:prstGeom prst="rect">
+            <a:avLst/>
+          </a:prstGeom>
+          <a:noFill/>
+        </p:spPr>
+        <p:txBody>
+          <a:bodyPr wrap="none" rtlCol="0">
+            <a:spAutoFit/>
+          </a:bodyPr>
+          <a:lstStyle/>
+          <a:p>
+            <a:r>
+              <a:rPr lang="en-US" sz="2000" dirty="0">
+                <a:latin typeface="Arial" panose="020B0604020202020204" pitchFamily="34" charset="0"/>
+                <a:cs typeface="Arial" panose="020B0604020202020204" pitchFamily="34" charset="0"/>
+              </a:rPr>
+              <a:t>2</a:t>
+            </a:r>
+          </a:p>
+        </p:txBody>
+      </p:sp>
+      <p:cxnSp>
+        <p:nvCxnSpPr>
+          <p:cNvPr id="96" name="Straight Connector 95">
+            <a:extLst>
+              <a:ext uri="{FF2B5EF4-FFF2-40B4-BE49-F238E27FC236}">
+                <a16:creationId xmlns:a16="http://schemas.microsoft.com/office/drawing/2014/main" id="{C518173F-653A-744B-92C1-6C2C574B5E81}"/>
+              </a:ext>
+            </a:extLst>
+          </p:cNvPr>
+          <p:cNvCxnSpPr/>
+          <p:nvPr/>
+        </p:nvCxnSpPr>
+        <p:spPr>
+          <a:xfrm flipV="1">
+            <a:off x="3678667" y="2851688"/>
+            <a:ext cx="5411089" cy="1466323"/>
+          </a:xfrm>
+          <a:prstGeom prst="line">
+            <a:avLst/>
+          </a:prstGeom>
+          <a:ln w="57150">
+            <a:solidFill>
+              <a:srgbClr val="C00000"/>
+            </a:solidFill>
+          </a:ln>
+        </p:spPr>
+        <p:style>
+          <a:lnRef idx="1">
+            <a:schemeClr val="accent1"/>
+          </a:lnRef>
+          <a:fillRef idx="0">
+            <a:schemeClr val="accent1"/>
+          </a:fillRef>
+          <a:effectRef idx="0">
+            <a:schemeClr val="accent1"/>
+          </a:effectRef>
+          <a:fontRef idx="minor">
+            <a:schemeClr val="tx1"/>
+          </a:fontRef>
+        </p:style>
+      </p:cxnSp>
+      <p:sp>
+        <p:nvSpPr>
+          <p:cNvPr id="3" name="Oval 2">
+            <a:extLst>
+              <a:ext uri="{FF2B5EF4-FFF2-40B4-BE49-F238E27FC236}">
+                <a16:creationId xmlns:a16="http://schemas.microsoft.com/office/drawing/2014/main" id="{99C1B4F7-29AD-EB4F-B1C4-E3A35BF22A95}"/>
+              </a:ext>
+            </a:extLst>
+          </p:cNvPr>
+          <p:cNvSpPr/>
+          <p:nvPr/>
+        </p:nvSpPr>
+        <p:spPr>
+          <a:xfrm>
+            <a:off x="8942522" y="2712203"/>
+            <a:ext cx="294468" cy="278970"/>
+          </a:xfrm>
+          <a:prstGeom prst="ellipse">
+            <a:avLst/>
+          </a:prstGeom>
+          <a:solidFill>
+            <a:srgbClr val="00B050"/>
+          </a:solidFill>
+        </p:spPr>
+        <p:style>
+          <a:lnRef idx="2">
+            <a:schemeClr val="accent1">
+              <a:shade val="50000"/>
+            </a:schemeClr>
+          </a:lnRef>
+          <a:fillRef idx="1">
+            <a:schemeClr val="accent1"/>
+          </a:fillRef>
+          <a:effectRef idx="0">
+            <a:schemeClr val="accent1"/>
+          </a:effectRef>
+          <a:fontRef idx="minor">
+            <a:schemeClr val="lt1"/>
+          </a:fontRef>
+        </p:style>
+        <p:txBody>
+          <a:bodyPr rtlCol="0" anchor="ctr"/>
+          <a:lstStyle/>
+          <a:p>
+            <a:pPr algn="ctr"/>
+            <a:endParaRPr lang="en-US"/>
+          </a:p>
+        </p:txBody>
+      </p:sp>
+      <p:sp>
+        <p:nvSpPr>
+          <p:cNvPr id="59" name="Oval 58">
+            <a:extLst>
+              <a:ext uri="{FF2B5EF4-FFF2-40B4-BE49-F238E27FC236}">
+                <a16:creationId xmlns:a16="http://schemas.microsoft.com/office/drawing/2014/main" id="{438EBBFA-45B5-9448-BB58-3E21FEE0C4CA}"/>
+              </a:ext>
+            </a:extLst>
+          </p:cNvPr>
+          <p:cNvSpPr/>
+          <p:nvPr/>
+        </p:nvSpPr>
+        <p:spPr>
+          <a:xfrm>
+            <a:off x="3531433" y="4179376"/>
+            <a:ext cx="294468" cy="278970"/>
+          </a:xfrm>
+          <a:prstGeom prst="ellipse">
+            <a:avLst/>
+          </a:prstGeom>
+          <a:solidFill>
+            <a:srgbClr val="00B050"/>
+          </a:solidFill>
+        </p:spPr>
+        <p:style>
+          <a:lnRef idx="2">
+            <a:schemeClr val="accent1">
+              <a:shade val="50000"/>
+            </a:schemeClr>
+          </a:lnRef>
+          <a:fillRef idx="1">
+            <a:schemeClr val="accent1"/>
+          </a:fillRef>
+          <a:effectRef idx="0">
+            <a:schemeClr val="accent1"/>
+          </a:effectRef>
+          <a:fontRef idx="minor">
+            <a:schemeClr val="lt1"/>
+          </a:fontRef>
+        </p:style>
+        <p:txBody>
+          <a:bodyPr rtlCol="0" anchor="ctr"/>
+          <a:lstStyle/>
+          <a:p>
+            <a:pPr algn="ctr"/>
+            <a:endParaRPr lang="en-US"/>
+          </a:p>
+        </p:txBody>
+      </p:sp>
+      <p:sp>
+        <p:nvSpPr>
+          <p:cNvPr id="97" name="TextBox 96">
+            <a:extLst>
+              <a:ext uri="{FF2B5EF4-FFF2-40B4-BE49-F238E27FC236}">
+                <a16:creationId xmlns:a16="http://schemas.microsoft.com/office/drawing/2014/main" id="{7C9B76D4-C3E5-3243-817C-DA17FB75959C}"/>
+              </a:ext>
+            </a:extLst>
+          </p:cNvPr>
+          <p:cNvSpPr txBox="1"/>
+          <p:nvPr/>
+        </p:nvSpPr>
+        <p:spPr>
+          <a:xfrm>
+            <a:off x="5428044" y="1885084"/>
+            <a:ext cx="1925527" cy="400110"/>
+          </a:xfrm>
+          <a:prstGeom prst="rect">
+            <a:avLst/>
+          </a:prstGeom>
+          <a:solidFill>
+            <a:srgbClr val="FFFFFF">
+              <a:alpha val="80000"/>
+            </a:srgbClr>
+          </a:solidFill>
+        </p:spPr>
+        <p:txBody>
+          <a:bodyPr wrap="none" rtlCol="0">
+            <a:spAutoFit/>
+          </a:bodyPr>
+          <a:lstStyle/>
+          <a:p>
+            <a:r>
+              <a:rPr lang="en-US" sz="2000" dirty="0">
+                <a:solidFill>
+                  <a:srgbClr val="0070C0"/>
+                </a:solidFill>
+                <a:latin typeface="Arial" panose="020B0604020202020204" pitchFamily="34" charset="0"/>
+                <a:cs typeface="Arial" panose="020B0604020202020204" pitchFamily="34" charset="0"/>
+              </a:rPr>
+              <a:t>SplitBoundary1</a:t>
+            </a:r>
+          </a:p>
+        </p:txBody>
+      </p:sp>
+      <p:sp>
+        <p:nvSpPr>
+          <p:cNvPr id="98" name="TextBox 97">
+            <a:extLst>
+              <a:ext uri="{FF2B5EF4-FFF2-40B4-BE49-F238E27FC236}">
+                <a16:creationId xmlns:a16="http://schemas.microsoft.com/office/drawing/2014/main" id="{DD6C4800-A04E-6C47-A47A-3790B0D0EBBD}"/>
+              </a:ext>
+            </a:extLst>
+          </p:cNvPr>
+          <p:cNvSpPr txBox="1"/>
+          <p:nvPr/>
+        </p:nvSpPr>
+        <p:spPr>
+          <a:xfrm>
+            <a:off x="3484156" y="3208042"/>
+            <a:ext cx="1925527" cy="400110"/>
+          </a:xfrm>
+          <a:prstGeom prst="rect">
+            <a:avLst/>
+          </a:prstGeom>
+          <a:solidFill>
+            <a:srgbClr val="FFFFFF">
+              <a:alpha val="80000"/>
+            </a:srgbClr>
+          </a:solidFill>
+        </p:spPr>
+        <p:txBody>
+          <a:bodyPr wrap="none" rtlCol="0">
+            <a:spAutoFit/>
+          </a:bodyPr>
+          <a:lstStyle/>
+          <a:p>
+            <a:r>
+              <a:rPr lang="en-US" sz="2000" dirty="0">
+                <a:solidFill>
+                  <a:srgbClr val="C00000"/>
+                </a:solidFill>
+                <a:latin typeface="Arial" panose="020B0604020202020204" pitchFamily="34" charset="0"/>
+                <a:cs typeface="Arial" panose="020B0604020202020204" pitchFamily="34" charset="0"/>
+              </a:rPr>
+              <a:t>SplitBoundary2</a:t>
+            </a:r>
+          </a:p>
+        </p:txBody>
+      </p:sp>
+      <p:sp>
+        <p:nvSpPr>
+          <p:cNvPr id="99" name="TextBox 98">
+            <a:extLst>
+              <a:ext uri="{FF2B5EF4-FFF2-40B4-BE49-F238E27FC236}">
+                <a16:creationId xmlns:a16="http://schemas.microsoft.com/office/drawing/2014/main" id="{60292BC9-F000-324B-8C39-46D0FD872D41}"/>
+              </a:ext>
+            </a:extLst>
+          </p:cNvPr>
+          <p:cNvSpPr txBox="1"/>
+          <p:nvPr/>
+        </p:nvSpPr>
+        <p:spPr>
+          <a:xfrm>
+            <a:off x="6038048" y="3974575"/>
+            <a:ext cx="1447832" cy="338554"/>
+          </a:xfrm>
+          <a:prstGeom prst="rect">
+            <a:avLst/>
+          </a:prstGeom>
+          <a:solidFill>
+            <a:srgbClr val="FFFFFF">
+              <a:alpha val="80000"/>
+            </a:srgbClr>
+          </a:solidFill>
+        </p:spPr>
+        <p:txBody>
+          <a:bodyPr wrap="none" rtlCol="0">
+            <a:spAutoFit/>
+          </a:bodyPr>
+          <a:lstStyle/>
+          <a:p>
+            <a:r>
+              <a:rPr lang="en-US" sz="1600" dirty="0" err="1">
+                <a:solidFill>
+                  <a:srgbClr val="FF0000"/>
+                </a:solidFill>
+                <a:latin typeface="Arial" panose="020B0604020202020204" pitchFamily="34" charset="0"/>
+                <a:cs typeface="Arial" panose="020B0604020202020204" pitchFamily="34" charset="0"/>
+              </a:rPr>
+              <a:t>NodeManifold</a:t>
+            </a:r>
+            <a:endParaRPr lang="en-US" sz="1600" dirty="0">
+              <a:solidFill>
+                <a:srgbClr val="FF0000"/>
+              </a:solidFill>
+              <a:latin typeface="Arial" panose="020B0604020202020204" pitchFamily="34" charset="0"/>
+              <a:cs typeface="Arial" panose="020B0604020202020204" pitchFamily="34" charset="0"/>
+            </a:endParaRPr>
           </a:p>
         </p:txBody>
       </p:sp>

</xml_diff>

<commit_message>
chore: removed interactive property assignment option from ANSYS_Interface which was not uses anywhere.
</commit_message>
<xml_diff>
--- a/doc/figures/SplitBoundaryUG_fig12.pptx
+++ b/doc/figures/SplitBoundaryUG_fig12.pptx
@@ -6,6 +6,7 @@
   </p:sldMasterIdLst>
   <p:sldIdLst>
     <p:sldId id="256" r:id="rId2"/>
+    <p:sldId id="257" r:id="rId3"/>
   </p:sldIdLst>
   <p:sldSz cx="12192000" cy="6858000"/>
   <p:notesSz cx="6858000" cy="9144000"/>
@@ -261,7 +262,7 @@
           <a:p>
             <a:fld id="{A923E91D-C2F6-8241-8A23-B73342C056DB}" type="datetimeFigureOut">
               <a:rPr lang="en-US" smtClean="0"/>
-              <a:t>1/25/20</a:t>
+              <a:t>10/1/20</a:t>
             </a:fld>
             <a:endParaRPr lang="en-US"/>
           </a:p>
@@ -461,7 +462,7 @@
           <a:p>
             <a:fld id="{A923E91D-C2F6-8241-8A23-B73342C056DB}" type="datetimeFigureOut">
               <a:rPr lang="en-US" smtClean="0"/>
-              <a:t>1/25/20</a:t>
+              <a:t>10/1/20</a:t>
             </a:fld>
             <a:endParaRPr lang="en-US"/>
           </a:p>
@@ -671,7 +672,7 @@
           <a:p>
             <a:fld id="{A923E91D-C2F6-8241-8A23-B73342C056DB}" type="datetimeFigureOut">
               <a:rPr lang="en-US" smtClean="0"/>
-              <a:t>1/25/20</a:t>
+              <a:t>10/1/20</a:t>
             </a:fld>
             <a:endParaRPr lang="en-US"/>
           </a:p>
@@ -871,7 +872,7 @@
           <a:p>
             <a:fld id="{A923E91D-C2F6-8241-8A23-B73342C056DB}" type="datetimeFigureOut">
               <a:rPr lang="en-US" smtClean="0"/>
-              <a:t>1/25/20</a:t>
+              <a:t>10/1/20</a:t>
             </a:fld>
             <a:endParaRPr lang="en-US"/>
           </a:p>
@@ -1147,7 +1148,7 @@
           <a:p>
             <a:fld id="{A923E91D-C2F6-8241-8A23-B73342C056DB}" type="datetimeFigureOut">
               <a:rPr lang="en-US" smtClean="0"/>
-              <a:t>1/25/20</a:t>
+              <a:t>10/1/20</a:t>
             </a:fld>
             <a:endParaRPr lang="en-US"/>
           </a:p>
@@ -1415,7 +1416,7 @@
           <a:p>
             <a:fld id="{A923E91D-C2F6-8241-8A23-B73342C056DB}" type="datetimeFigureOut">
               <a:rPr lang="en-US" smtClean="0"/>
-              <a:t>1/25/20</a:t>
+              <a:t>10/1/20</a:t>
             </a:fld>
             <a:endParaRPr lang="en-US"/>
           </a:p>
@@ -1830,7 +1831,7 @@
           <a:p>
             <a:fld id="{A923E91D-C2F6-8241-8A23-B73342C056DB}" type="datetimeFigureOut">
               <a:rPr lang="en-US" smtClean="0"/>
-              <a:t>1/25/20</a:t>
+              <a:t>10/1/20</a:t>
             </a:fld>
             <a:endParaRPr lang="en-US"/>
           </a:p>
@@ -1972,7 +1973,7 @@
           <a:p>
             <a:fld id="{A923E91D-C2F6-8241-8A23-B73342C056DB}" type="datetimeFigureOut">
               <a:rPr lang="en-US" smtClean="0"/>
-              <a:t>1/25/20</a:t>
+              <a:t>10/1/20</a:t>
             </a:fld>
             <a:endParaRPr lang="en-US"/>
           </a:p>
@@ -2085,7 +2086,7 @@
           <a:p>
             <a:fld id="{A923E91D-C2F6-8241-8A23-B73342C056DB}" type="datetimeFigureOut">
               <a:rPr lang="en-US" smtClean="0"/>
-              <a:t>1/25/20</a:t>
+              <a:t>10/1/20</a:t>
             </a:fld>
             <a:endParaRPr lang="en-US"/>
           </a:p>
@@ -2398,7 +2399,7 @@
           <a:p>
             <a:fld id="{A923E91D-C2F6-8241-8A23-B73342C056DB}" type="datetimeFigureOut">
               <a:rPr lang="en-US" smtClean="0"/>
-              <a:t>1/25/20</a:t>
+              <a:t>10/1/20</a:t>
             </a:fld>
             <a:endParaRPr lang="en-US"/>
           </a:p>
@@ -2687,7 +2688,7 @@
           <a:p>
             <a:fld id="{A923E91D-C2F6-8241-8A23-B73342C056DB}" type="datetimeFigureOut">
               <a:rPr lang="en-US" smtClean="0"/>
-              <a:t>1/25/20</a:t>
+              <a:t>10/1/20</a:t>
             </a:fld>
             <a:endParaRPr lang="en-US"/>
           </a:p>
@@ -2930,7 +2931,7 @@
           <a:p>
             <a:fld id="{A923E91D-C2F6-8241-8A23-B73342C056DB}" type="datetimeFigureOut">
               <a:rPr lang="en-US" smtClean="0"/>
-              <a:t>1/25/20</a:t>
+              <a:t>10/1/20</a:t>
             </a:fld>
             <a:endParaRPr lang="en-US"/>
           </a:p>
@@ -5827,6 +5828,1785 @@
 </p:sld>
 </file>
 
+<file path=ppt/slides/slide2.xml><?xml version="1.0" encoding="utf-8"?>
+<p:sld xmlns:a="http://schemas.openxmlformats.org/drawingml/2006/main" xmlns:r="http://schemas.openxmlformats.org/officeDocument/2006/relationships" xmlns:p="http://schemas.openxmlformats.org/presentationml/2006/main">
+  <p:cSld>
+    <p:spTree>
+      <p:nvGrpSpPr>
+        <p:cNvPr id="1" name=""/>
+        <p:cNvGrpSpPr/>
+        <p:nvPr/>
+      </p:nvGrpSpPr>
+      <p:grpSpPr>
+        <a:xfrm>
+          <a:off x="0" y="0"/>
+          <a:ext cx="0" cy="0"/>
+          <a:chOff x="0" y="0"/>
+          <a:chExt cx="0" cy="0"/>
+        </a:xfrm>
+      </p:grpSpPr>
+      <p:pic>
+        <p:nvPicPr>
+          <p:cNvPr id="2" name="Picture 1">
+            <a:extLst>
+              <a:ext uri="{FF2B5EF4-FFF2-40B4-BE49-F238E27FC236}">
+                <a16:creationId xmlns:a16="http://schemas.microsoft.com/office/drawing/2014/main" id="{524EB329-0E20-3E4A-9F13-D438DA444D5E}"/>
+              </a:ext>
+            </a:extLst>
+          </p:cNvPr>
+          <p:cNvPicPr>
+            <a:picLocks noChangeAspect="1"/>
+          </p:cNvPicPr>
+          <p:nvPr/>
+        </p:nvPicPr>
+        <p:blipFill rotWithShape="1">
+          <a:blip r:embed="rId2"/>
+          <a:srcRect l="14785" t="28448" r="9947" b="22795"/>
+          <a:stretch/>
+        </p:blipFill>
+        <p:spPr>
+          <a:xfrm>
+            <a:off x="3678667" y="1676400"/>
+            <a:ext cx="5411089" cy="3505200"/>
+          </a:xfrm>
+          <a:prstGeom prst="rect">
+            <a:avLst/>
+          </a:prstGeom>
+          <a:ln w="19050">
+            <a:solidFill>
+              <a:schemeClr val="tx1"/>
+            </a:solidFill>
+          </a:ln>
+        </p:spPr>
+      </p:pic>
+      <p:sp>
+        <p:nvSpPr>
+          <p:cNvPr id="7" name="Freeform 6">
+            <a:extLst>
+              <a:ext uri="{FF2B5EF4-FFF2-40B4-BE49-F238E27FC236}">
+                <a16:creationId xmlns:a16="http://schemas.microsoft.com/office/drawing/2014/main" id="{B3241FEC-4E9A-8446-8AE6-598F242ADAE2}"/>
+              </a:ext>
+            </a:extLst>
+          </p:cNvPr>
+          <p:cNvSpPr/>
+          <p:nvPr/>
+        </p:nvSpPr>
+        <p:spPr>
+          <a:xfrm>
+            <a:off x="3608832" y="2852928"/>
+            <a:ext cx="5529072" cy="1475232"/>
+          </a:xfrm>
+          <a:custGeom>
+            <a:avLst/>
+            <a:gdLst>
+              <a:gd name="connsiteX0" fmla="*/ 0 w 5529072"/>
+              <a:gd name="connsiteY0" fmla="*/ 1475232 h 1475232"/>
+              <a:gd name="connsiteX1" fmla="*/ 707136 w 5529072"/>
+              <a:gd name="connsiteY1" fmla="*/ 1152144 h 1475232"/>
+              <a:gd name="connsiteX2" fmla="*/ 1389888 w 5529072"/>
+              <a:gd name="connsiteY2" fmla="*/ 993648 h 1475232"/>
+              <a:gd name="connsiteX3" fmla="*/ 2078736 w 5529072"/>
+              <a:gd name="connsiteY3" fmla="*/ 810768 h 1475232"/>
+              <a:gd name="connsiteX4" fmla="*/ 2743200 w 5529072"/>
+              <a:gd name="connsiteY4" fmla="*/ 621792 h 1475232"/>
+              <a:gd name="connsiteX5" fmla="*/ 3419856 w 5529072"/>
+              <a:gd name="connsiteY5" fmla="*/ 414528 h 1475232"/>
+              <a:gd name="connsiteX6" fmla="*/ 4078224 w 5529072"/>
+              <a:gd name="connsiteY6" fmla="*/ 237744 h 1475232"/>
+              <a:gd name="connsiteX7" fmla="*/ 4767072 w 5529072"/>
+              <a:gd name="connsiteY7" fmla="*/ 48768 h 1475232"/>
+              <a:gd name="connsiteX8" fmla="*/ 5529072 w 5529072"/>
+              <a:gd name="connsiteY8" fmla="*/ 0 h 1475232"/>
+              <a:gd name="connsiteX9" fmla="*/ 4809744 w 5529072"/>
+              <a:gd name="connsiteY9" fmla="*/ 365760 h 1475232"/>
+              <a:gd name="connsiteX10" fmla="*/ 4151376 w 5529072"/>
+              <a:gd name="connsiteY10" fmla="*/ 524256 h 1475232"/>
+              <a:gd name="connsiteX11" fmla="*/ 3486912 w 5529072"/>
+              <a:gd name="connsiteY11" fmla="*/ 707136 h 1475232"/>
+              <a:gd name="connsiteX12" fmla="*/ 2810256 w 5529072"/>
+              <a:gd name="connsiteY12" fmla="*/ 871728 h 1475232"/>
+              <a:gd name="connsiteX13" fmla="*/ 2170176 w 5529072"/>
+              <a:gd name="connsiteY13" fmla="*/ 1060704 h 1475232"/>
+              <a:gd name="connsiteX14" fmla="*/ 1450848 w 5529072"/>
+              <a:gd name="connsiteY14" fmla="*/ 1249680 h 1475232"/>
+              <a:gd name="connsiteX15" fmla="*/ 774192 w 5529072"/>
+              <a:gd name="connsiteY15" fmla="*/ 1432560 h 1475232"/>
+              <a:gd name="connsiteX16" fmla="*/ 0 w 5529072"/>
+              <a:gd name="connsiteY16" fmla="*/ 1475232 h 1475232"/>
+            </a:gdLst>
+            <a:ahLst/>
+            <a:cxnLst>
+              <a:cxn ang="0">
+                <a:pos x="connsiteX0" y="connsiteY0"/>
+              </a:cxn>
+              <a:cxn ang="0">
+                <a:pos x="connsiteX1" y="connsiteY1"/>
+              </a:cxn>
+              <a:cxn ang="0">
+                <a:pos x="connsiteX2" y="connsiteY2"/>
+              </a:cxn>
+              <a:cxn ang="0">
+                <a:pos x="connsiteX3" y="connsiteY3"/>
+              </a:cxn>
+              <a:cxn ang="0">
+                <a:pos x="connsiteX4" y="connsiteY4"/>
+              </a:cxn>
+              <a:cxn ang="0">
+                <a:pos x="connsiteX5" y="connsiteY5"/>
+              </a:cxn>
+              <a:cxn ang="0">
+                <a:pos x="connsiteX6" y="connsiteY6"/>
+              </a:cxn>
+              <a:cxn ang="0">
+                <a:pos x="connsiteX7" y="connsiteY7"/>
+              </a:cxn>
+              <a:cxn ang="0">
+                <a:pos x="connsiteX8" y="connsiteY8"/>
+              </a:cxn>
+              <a:cxn ang="0">
+                <a:pos x="connsiteX9" y="connsiteY9"/>
+              </a:cxn>
+              <a:cxn ang="0">
+                <a:pos x="connsiteX10" y="connsiteY10"/>
+              </a:cxn>
+              <a:cxn ang="0">
+                <a:pos x="connsiteX11" y="connsiteY11"/>
+              </a:cxn>
+              <a:cxn ang="0">
+                <a:pos x="connsiteX12" y="connsiteY12"/>
+              </a:cxn>
+              <a:cxn ang="0">
+                <a:pos x="connsiteX13" y="connsiteY13"/>
+              </a:cxn>
+              <a:cxn ang="0">
+                <a:pos x="connsiteX14" y="connsiteY14"/>
+              </a:cxn>
+              <a:cxn ang="0">
+                <a:pos x="connsiteX15" y="connsiteY15"/>
+              </a:cxn>
+              <a:cxn ang="0">
+                <a:pos x="connsiteX16" y="connsiteY16"/>
+              </a:cxn>
+            </a:cxnLst>
+            <a:rect l="l" t="t" r="r" b="b"/>
+            <a:pathLst>
+              <a:path w="5529072" h="1475232">
+                <a:moveTo>
+                  <a:pt x="0" y="1475232"/>
+                </a:moveTo>
+                <a:lnTo>
+                  <a:pt x="707136" y="1152144"/>
+                </a:lnTo>
+                <a:lnTo>
+                  <a:pt x="1389888" y="993648"/>
+                </a:lnTo>
+                <a:lnTo>
+                  <a:pt x="2078736" y="810768"/>
+                </a:lnTo>
+                <a:lnTo>
+                  <a:pt x="2743200" y="621792"/>
+                </a:lnTo>
+                <a:lnTo>
+                  <a:pt x="3419856" y="414528"/>
+                </a:lnTo>
+                <a:lnTo>
+                  <a:pt x="4078224" y="237744"/>
+                </a:lnTo>
+                <a:lnTo>
+                  <a:pt x="4767072" y="48768"/>
+                </a:lnTo>
+                <a:lnTo>
+                  <a:pt x="5529072" y="0"/>
+                </a:lnTo>
+                <a:lnTo>
+                  <a:pt x="4809744" y="365760"/>
+                </a:lnTo>
+                <a:lnTo>
+                  <a:pt x="4151376" y="524256"/>
+                </a:lnTo>
+                <a:lnTo>
+                  <a:pt x="3486912" y="707136"/>
+                </a:lnTo>
+                <a:lnTo>
+                  <a:pt x="2810256" y="871728"/>
+                </a:lnTo>
+                <a:lnTo>
+                  <a:pt x="2170176" y="1060704"/>
+                </a:lnTo>
+                <a:lnTo>
+                  <a:pt x="1450848" y="1249680"/>
+                </a:lnTo>
+                <a:lnTo>
+                  <a:pt x="774192" y="1432560"/>
+                </a:lnTo>
+                <a:lnTo>
+                  <a:pt x="0" y="1475232"/>
+                </a:lnTo>
+                <a:close/>
+              </a:path>
+            </a:pathLst>
+          </a:custGeom>
+        </p:spPr>
+        <p:style>
+          <a:lnRef idx="2">
+            <a:schemeClr val="accent1">
+              <a:shade val="50000"/>
+            </a:schemeClr>
+          </a:lnRef>
+          <a:fillRef idx="1">
+            <a:schemeClr val="accent1"/>
+          </a:fillRef>
+          <a:effectRef idx="0">
+            <a:schemeClr val="accent1"/>
+          </a:effectRef>
+          <a:fontRef idx="minor">
+            <a:schemeClr val="lt1"/>
+          </a:fontRef>
+        </p:style>
+        <p:txBody>
+          <a:bodyPr rtlCol="0" anchor="ctr"/>
+          <a:lstStyle/>
+          <a:p>
+            <a:pPr algn="ctr"/>
+            <a:endParaRPr lang="en-US"/>
+          </a:p>
+        </p:txBody>
+      </p:sp>
+      <p:sp>
+        <p:nvSpPr>
+          <p:cNvPr id="6" name="Chord 5">
+            <a:extLst>
+              <a:ext uri="{FF2B5EF4-FFF2-40B4-BE49-F238E27FC236}">
+                <a16:creationId xmlns:a16="http://schemas.microsoft.com/office/drawing/2014/main" id="{67C57186-3610-834E-A156-393DBB9A5108}"/>
+              </a:ext>
+            </a:extLst>
+          </p:cNvPr>
+          <p:cNvSpPr/>
+          <p:nvPr/>
+        </p:nvSpPr>
+        <p:spPr>
+          <a:xfrm rot="5801687">
+            <a:off x="8212695" y="2722846"/>
+            <a:ext cx="255722" cy="286719"/>
+          </a:xfrm>
+          <a:prstGeom prst="chord">
+            <a:avLst/>
+          </a:prstGeom>
+          <a:solidFill>
+            <a:srgbClr val="00B050"/>
+          </a:solidFill>
+        </p:spPr>
+        <p:style>
+          <a:lnRef idx="2">
+            <a:schemeClr val="accent1">
+              <a:shade val="50000"/>
+            </a:schemeClr>
+          </a:lnRef>
+          <a:fillRef idx="1">
+            <a:schemeClr val="accent1"/>
+          </a:fillRef>
+          <a:effectRef idx="0">
+            <a:schemeClr val="accent1"/>
+          </a:effectRef>
+          <a:fontRef idx="minor">
+            <a:schemeClr val="lt1"/>
+          </a:fontRef>
+        </p:style>
+        <p:txBody>
+          <a:bodyPr rtlCol="0" anchor="ctr"/>
+          <a:lstStyle/>
+          <a:p>
+            <a:pPr algn="ctr"/>
+            <a:endParaRPr lang="en-US"/>
+          </a:p>
+        </p:txBody>
+      </p:sp>
+      <p:sp>
+        <p:nvSpPr>
+          <p:cNvPr id="44" name="Chord 43">
+            <a:extLst>
+              <a:ext uri="{FF2B5EF4-FFF2-40B4-BE49-F238E27FC236}">
+                <a16:creationId xmlns:a16="http://schemas.microsoft.com/office/drawing/2014/main" id="{D93A7DE7-5F69-8F42-81D2-770CA8658211}"/>
+              </a:ext>
+            </a:extLst>
+          </p:cNvPr>
+          <p:cNvSpPr/>
+          <p:nvPr/>
+        </p:nvSpPr>
+        <p:spPr>
+          <a:xfrm rot="5789241" flipH="1" flipV="1">
+            <a:off x="8330293" y="3085282"/>
+            <a:ext cx="255722" cy="286719"/>
+          </a:xfrm>
+          <a:prstGeom prst="chord">
+            <a:avLst/>
+          </a:prstGeom>
+          <a:solidFill>
+            <a:srgbClr val="FFFF00"/>
+          </a:solidFill>
+        </p:spPr>
+        <p:style>
+          <a:lnRef idx="2">
+            <a:schemeClr val="accent1">
+              <a:shade val="50000"/>
+            </a:schemeClr>
+          </a:lnRef>
+          <a:fillRef idx="1">
+            <a:schemeClr val="accent1"/>
+          </a:fillRef>
+          <a:effectRef idx="0">
+            <a:schemeClr val="accent1"/>
+          </a:effectRef>
+          <a:fontRef idx="minor">
+            <a:schemeClr val="lt1"/>
+          </a:fontRef>
+        </p:style>
+        <p:txBody>
+          <a:bodyPr rtlCol="0" anchor="ctr"/>
+          <a:lstStyle/>
+          <a:p>
+            <a:pPr algn="ctr"/>
+            <a:endParaRPr lang="en-US"/>
+          </a:p>
+        </p:txBody>
+      </p:sp>
+      <p:grpSp>
+        <p:nvGrpSpPr>
+          <p:cNvPr id="8" name="Group 7">
+            <a:extLst>
+              <a:ext uri="{FF2B5EF4-FFF2-40B4-BE49-F238E27FC236}">
+                <a16:creationId xmlns:a16="http://schemas.microsoft.com/office/drawing/2014/main" id="{541D774E-8A07-FD40-8F38-DCC7810BAB03}"/>
+              </a:ext>
+            </a:extLst>
+          </p:cNvPr>
+          <p:cNvGrpSpPr/>
+          <p:nvPr/>
+        </p:nvGrpSpPr>
+        <p:grpSpPr>
+          <a:xfrm>
+            <a:off x="7521843" y="2927575"/>
+            <a:ext cx="390858" cy="623752"/>
+            <a:chOff x="8388485" y="2952338"/>
+            <a:chExt cx="390858" cy="623752"/>
+          </a:xfrm>
+        </p:grpSpPr>
+        <p:sp>
+          <p:nvSpPr>
+            <p:cNvPr id="45" name="Chord 44">
+              <a:extLst>
+                <a:ext uri="{FF2B5EF4-FFF2-40B4-BE49-F238E27FC236}">
+                  <a16:creationId xmlns:a16="http://schemas.microsoft.com/office/drawing/2014/main" id="{29073046-8A2A-FE46-93A2-41BD2B506D70}"/>
+                </a:ext>
+              </a:extLst>
+            </p:cNvPr>
+            <p:cNvSpPr/>
+            <p:nvPr/>
+          </p:nvSpPr>
+          <p:spPr>
+            <a:xfrm rot="5801687">
+              <a:off x="8403984" y="2936839"/>
+              <a:ext cx="255722" cy="286719"/>
+            </a:xfrm>
+            <a:prstGeom prst="chord">
+              <a:avLst/>
+            </a:prstGeom>
+            <a:solidFill>
+              <a:srgbClr val="00B050"/>
+            </a:solidFill>
+          </p:spPr>
+          <p:style>
+            <a:lnRef idx="2">
+              <a:schemeClr val="accent1">
+                <a:shade val="50000"/>
+              </a:schemeClr>
+            </a:lnRef>
+            <a:fillRef idx="1">
+              <a:schemeClr val="accent1"/>
+            </a:fillRef>
+            <a:effectRef idx="0">
+              <a:schemeClr val="accent1"/>
+            </a:effectRef>
+            <a:fontRef idx="minor">
+              <a:schemeClr val="lt1"/>
+            </a:fontRef>
+          </p:style>
+          <p:txBody>
+            <a:bodyPr rtlCol="0" anchor="ctr"/>
+            <a:lstStyle/>
+            <a:p>
+              <a:pPr algn="ctr"/>
+              <a:endParaRPr lang="en-US"/>
+            </a:p>
+          </p:txBody>
+        </p:sp>
+        <p:sp>
+          <p:nvSpPr>
+            <p:cNvPr id="46" name="Chord 45">
+              <a:extLst>
+                <a:ext uri="{FF2B5EF4-FFF2-40B4-BE49-F238E27FC236}">
+                  <a16:creationId xmlns:a16="http://schemas.microsoft.com/office/drawing/2014/main" id="{B011B9CF-1DE7-124E-B783-4D5B73ADD6E0}"/>
+                </a:ext>
+              </a:extLst>
+            </p:cNvPr>
+            <p:cNvSpPr/>
+            <p:nvPr/>
+          </p:nvSpPr>
+          <p:spPr>
+            <a:xfrm rot="5789241" flipH="1" flipV="1">
+              <a:off x="8508123" y="3304869"/>
+              <a:ext cx="255722" cy="286719"/>
+            </a:xfrm>
+            <a:prstGeom prst="chord">
+              <a:avLst/>
+            </a:prstGeom>
+            <a:solidFill>
+              <a:srgbClr val="FFFF00"/>
+            </a:solidFill>
+          </p:spPr>
+          <p:style>
+            <a:lnRef idx="2">
+              <a:schemeClr val="accent1">
+                <a:shade val="50000"/>
+              </a:schemeClr>
+            </a:lnRef>
+            <a:fillRef idx="1">
+              <a:schemeClr val="accent1"/>
+            </a:fillRef>
+            <a:effectRef idx="0">
+              <a:schemeClr val="accent1"/>
+            </a:effectRef>
+            <a:fontRef idx="minor">
+              <a:schemeClr val="lt1"/>
+            </a:fontRef>
+          </p:style>
+          <p:txBody>
+            <a:bodyPr rtlCol="0" anchor="ctr"/>
+            <a:lstStyle/>
+            <a:p>
+              <a:pPr algn="ctr"/>
+              <a:endParaRPr lang="en-US"/>
+            </a:p>
+          </p:txBody>
+        </p:sp>
+      </p:grpSp>
+      <p:grpSp>
+        <p:nvGrpSpPr>
+          <p:cNvPr id="47" name="Group 46">
+            <a:extLst>
+              <a:ext uri="{FF2B5EF4-FFF2-40B4-BE49-F238E27FC236}">
+                <a16:creationId xmlns:a16="http://schemas.microsoft.com/office/drawing/2014/main" id="{0B189B2E-5FB7-BF4C-A811-47DB63FD9DAC}"/>
+              </a:ext>
+            </a:extLst>
+          </p:cNvPr>
+          <p:cNvGrpSpPr/>
+          <p:nvPr/>
+        </p:nvGrpSpPr>
+        <p:grpSpPr>
+          <a:xfrm>
+            <a:off x="6855434" y="3092602"/>
+            <a:ext cx="381598" cy="641212"/>
+            <a:chOff x="8355451" y="2888643"/>
+            <a:chExt cx="381598" cy="641212"/>
+          </a:xfrm>
+        </p:grpSpPr>
+        <p:sp>
+          <p:nvSpPr>
+            <p:cNvPr id="48" name="Chord 47">
+              <a:extLst>
+                <a:ext uri="{FF2B5EF4-FFF2-40B4-BE49-F238E27FC236}">
+                  <a16:creationId xmlns:a16="http://schemas.microsoft.com/office/drawing/2014/main" id="{C19A910C-2900-074F-9B60-34BBEBF142F6}"/>
+                </a:ext>
+              </a:extLst>
+            </p:cNvPr>
+            <p:cNvSpPr/>
+            <p:nvPr/>
+          </p:nvSpPr>
+          <p:spPr>
+            <a:xfrm rot="5801687">
+              <a:off x="8370950" y="2873144"/>
+              <a:ext cx="255722" cy="286719"/>
+            </a:xfrm>
+            <a:prstGeom prst="chord">
+              <a:avLst/>
+            </a:prstGeom>
+            <a:solidFill>
+              <a:srgbClr val="00B050"/>
+            </a:solidFill>
+          </p:spPr>
+          <p:style>
+            <a:lnRef idx="2">
+              <a:schemeClr val="accent1">
+                <a:shade val="50000"/>
+              </a:schemeClr>
+            </a:lnRef>
+            <a:fillRef idx="1">
+              <a:schemeClr val="accent1"/>
+            </a:fillRef>
+            <a:effectRef idx="0">
+              <a:schemeClr val="accent1"/>
+            </a:effectRef>
+            <a:fontRef idx="minor">
+              <a:schemeClr val="lt1"/>
+            </a:fontRef>
+          </p:style>
+          <p:txBody>
+            <a:bodyPr rtlCol="0" anchor="ctr"/>
+            <a:lstStyle/>
+            <a:p>
+              <a:pPr algn="ctr"/>
+              <a:endParaRPr lang="en-US"/>
+            </a:p>
+          </p:txBody>
+        </p:sp>
+        <p:sp>
+          <p:nvSpPr>
+            <p:cNvPr id="49" name="Chord 48">
+              <a:extLst>
+                <a:ext uri="{FF2B5EF4-FFF2-40B4-BE49-F238E27FC236}">
+                  <a16:creationId xmlns:a16="http://schemas.microsoft.com/office/drawing/2014/main" id="{D878F4B8-2C0F-D240-8CC5-3800B9FA72C0}"/>
+                </a:ext>
+              </a:extLst>
+            </p:cNvPr>
+            <p:cNvSpPr/>
+            <p:nvPr/>
+          </p:nvSpPr>
+          <p:spPr>
+            <a:xfrm rot="5789241" flipH="1" flipV="1">
+              <a:off x="8465829" y="3258634"/>
+              <a:ext cx="255722" cy="286719"/>
+            </a:xfrm>
+            <a:prstGeom prst="chord">
+              <a:avLst/>
+            </a:prstGeom>
+            <a:solidFill>
+              <a:srgbClr val="FFFF00"/>
+            </a:solidFill>
+          </p:spPr>
+          <p:style>
+            <a:lnRef idx="2">
+              <a:schemeClr val="accent1">
+                <a:shade val="50000"/>
+              </a:schemeClr>
+            </a:lnRef>
+            <a:fillRef idx="1">
+              <a:schemeClr val="accent1"/>
+            </a:fillRef>
+            <a:effectRef idx="0">
+              <a:schemeClr val="accent1"/>
+            </a:effectRef>
+            <a:fontRef idx="minor">
+              <a:schemeClr val="lt1"/>
+            </a:fontRef>
+          </p:style>
+          <p:txBody>
+            <a:bodyPr rtlCol="0" anchor="ctr"/>
+            <a:lstStyle/>
+            <a:p>
+              <a:pPr algn="ctr"/>
+              <a:endParaRPr lang="en-US"/>
+            </a:p>
+          </p:txBody>
+        </p:sp>
+      </p:grpSp>
+      <p:grpSp>
+        <p:nvGrpSpPr>
+          <p:cNvPr id="50" name="Group 49">
+            <a:extLst>
+              <a:ext uri="{FF2B5EF4-FFF2-40B4-BE49-F238E27FC236}">
+                <a16:creationId xmlns:a16="http://schemas.microsoft.com/office/drawing/2014/main" id="{E225971E-29A4-954C-AE91-26C2970DC441}"/>
+              </a:ext>
+            </a:extLst>
+          </p:cNvPr>
+          <p:cNvGrpSpPr/>
+          <p:nvPr/>
+        </p:nvGrpSpPr>
+        <p:grpSpPr>
+          <a:xfrm>
+            <a:off x="5501656" y="3485012"/>
+            <a:ext cx="430772" cy="608950"/>
+            <a:chOff x="8364232" y="2919649"/>
+            <a:chExt cx="430772" cy="608950"/>
+          </a:xfrm>
+        </p:grpSpPr>
+        <p:sp>
+          <p:nvSpPr>
+            <p:cNvPr id="51" name="Chord 50">
+              <a:extLst>
+                <a:ext uri="{FF2B5EF4-FFF2-40B4-BE49-F238E27FC236}">
+                  <a16:creationId xmlns:a16="http://schemas.microsoft.com/office/drawing/2014/main" id="{BF89DF20-0198-B14F-A849-817D6B3ED5F9}"/>
+                </a:ext>
+              </a:extLst>
+            </p:cNvPr>
+            <p:cNvSpPr/>
+            <p:nvPr/>
+          </p:nvSpPr>
+          <p:spPr>
+            <a:xfrm rot="5801687">
+              <a:off x="8379731" y="2904150"/>
+              <a:ext cx="255722" cy="286719"/>
+            </a:xfrm>
+            <a:prstGeom prst="chord">
+              <a:avLst/>
+            </a:prstGeom>
+            <a:solidFill>
+              <a:srgbClr val="00B050"/>
+            </a:solidFill>
+          </p:spPr>
+          <p:style>
+            <a:lnRef idx="2">
+              <a:schemeClr val="accent1">
+                <a:shade val="50000"/>
+              </a:schemeClr>
+            </a:lnRef>
+            <a:fillRef idx="1">
+              <a:schemeClr val="accent1"/>
+            </a:fillRef>
+            <a:effectRef idx="0">
+              <a:schemeClr val="accent1"/>
+            </a:effectRef>
+            <a:fontRef idx="minor">
+              <a:schemeClr val="lt1"/>
+            </a:fontRef>
+          </p:style>
+          <p:txBody>
+            <a:bodyPr rtlCol="0" anchor="ctr"/>
+            <a:lstStyle/>
+            <a:p>
+              <a:pPr algn="ctr"/>
+              <a:endParaRPr lang="en-US"/>
+            </a:p>
+          </p:txBody>
+        </p:sp>
+        <p:sp>
+          <p:nvSpPr>
+            <p:cNvPr id="52" name="Chord 51">
+              <a:extLst>
+                <a:ext uri="{FF2B5EF4-FFF2-40B4-BE49-F238E27FC236}">
+                  <a16:creationId xmlns:a16="http://schemas.microsoft.com/office/drawing/2014/main" id="{7085B582-DBFA-9A4A-B300-8AB5EF543EAB}"/>
+                </a:ext>
+              </a:extLst>
+            </p:cNvPr>
+            <p:cNvSpPr/>
+            <p:nvPr/>
+          </p:nvSpPr>
+          <p:spPr>
+            <a:xfrm rot="5789241" flipH="1" flipV="1">
+              <a:off x="8523784" y="3257378"/>
+              <a:ext cx="255722" cy="286719"/>
+            </a:xfrm>
+            <a:prstGeom prst="chord">
+              <a:avLst/>
+            </a:prstGeom>
+            <a:solidFill>
+              <a:srgbClr val="FFFF00"/>
+            </a:solidFill>
+          </p:spPr>
+          <p:style>
+            <a:lnRef idx="2">
+              <a:schemeClr val="accent1">
+                <a:shade val="50000"/>
+              </a:schemeClr>
+            </a:lnRef>
+            <a:fillRef idx="1">
+              <a:schemeClr val="accent1"/>
+            </a:fillRef>
+            <a:effectRef idx="0">
+              <a:schemeClr val="accent1"/>
+            </a:effectRef>
+            <a:fontRef idx="minor">
+              <a:schemeClr val="lt1"/>
+            </a:fontRef>
+          </p:style>
+          <p:txBody>
+            <a:bodyPr rtlCol="0" anchor="ctr"/>
+            <a:lstStyle/>
+            <a:p>
+              <a:pPr algn="ctr"/>
+              <a:endParaRPr lang="en-US"/>
+            </a:p>
+          </p:txBody>
+        </p:sp>
+      </p:grpSp>
+      <p:grpSp>
+        <p:nvGrpSpPr>
+          <p:cNvPr id="53" name="Group 52">
+            <a:extLst>
+              <a:ext uri="{FF2B5EF4-FFF2-40B4-BE49-F238E27FC236}">
+                <a16:creationId xmlns:a16="http://schemas.microsoft.com/office/drawing/2014/main" id="{5323B2C6-F455-464B-8B90-5E37F8104359}"/>
+              </a:ext>
+            </a:extLst>
+          </p:cNvPr>
+          <p:cNvGrpSpPr/>
+          <p:nvPr/>
+        </p:nvGrpSpPr>
+        <p:grpSpPr>
+          <a:xfrm>
+            <a:off x="4163636" y="3825345"/>
+            <a:ext cx="369754" cy="621547"/>
+            <a:chOff x="8381022" y="2890829"/>
+            <a:chExt cx="369754" cy="621547"/>
+          </a:xfrm>
+        </p:grpSpPr>
+        <p:sp>
+          <p:nvSpPr>
+            <p:cNvPr id="54" name="Chord 53">
+              <a:extLst>
+                <a:ext uri="{FF2B5EF4-FFF2-40B4-BE49-F238E27FC236}">
+                  <a16:creationId xmlns:a16="http://schemas.microsoft.com/office/drawing/2014/main" id="{FC65A544-18F2-7145-B899-AF5D0A15ACB5}"/>
+                </a:ext>
+              </a:extLst>
+            </p:cNvPr>
+            <p:cNvSpPr/>
+            <p:nvPr/>
+          </p:nvSpPr>
+          <p:spPr>
+            <a:xfrm rot="5801687">
+              <a:off x="8396521" y="2875330"/>
+              <a:ext cx="255722" cy="286719"/>
+            </a:xfrm>
+            <a:prstGeom prst="chord">
+              <a:avLst/>
+            </a:prstGeom>
+            <a:solidFill>
+              <a:srgbClr val="00B050"/>
+            </a:solidFill>
+          </p:spPr>
+          <p:style>
+            <a:lnRef idx="2">
+              <a:schemeClr val="accent1">
+                <a:shade val="50000"/>
+              </a:schemeClr>
+            </a:lnRef>
+            <a:fillRef idx="1">
+              <a:schemeClr val="accent1"/>
+            </a:fillRef>
+            <a:effectRef idx="0">
+              <a:schemeClr val="accent1"/>
+            </a:effectRef>
+            <a:fontRef idx="minor">
+              <a:schemeClr val="lt1"/>
+            </a:fontRef>
+          </p:style>
+          <p:txBody>
+            <a:bodyPr rtlCol="0" anchor="ctr"/>
+            <a:lstStyle/>
+            <a:p>
+              <a:pPr algn="ctr"/>
+              <a:endParaRPr lang="en-US"/>
+            </a:p>
+          </p:txBody>
+        </p:sp>
+        <p:sp>
+          <p:nvSpPr>
+            <p:cNvPr id="55" name="Chord 54">
+              <a:extLst>
+                <a:ext uri="{FF2B5EF4-FFF2-40B4-BE49-F238E27FC236}">
+                  <a16:creationId xmlns:a16="http://schemas.microsoft.com/office/drawing/2014/main" id="{8256E49F-C7EB-7C44-A9A2-B17EA65AD822}"/>
+                </a:ext>
+              </a:extLst>
+            </p:cNvPr>
+            <p:cNvSpPr/>
+            <p:nvPr/>
+          </p:nvSpPr>
+          <p:spPr>
+            <a:xfrm rot="5789241" flipH="1" flipV="1">
+              <a:off x="8479556" y="3241155"/>
+              <a:ext cx="255722" cy="286719"/>
+            </a:xfrm>
+            <a:prstGeom prst="chord">
+              <a:avLst/>
+            </a:prstGeom>
+            <a:solidFill>
+              <a:srgbClr val="FFFF00"/>
+            </a:solidFill>
+          </p:spPr>
+          <p:style>
+            <a:lnRef idx="2">
+              <a:schemeClr val="accent1">
+                <a:shade val="50000"/>
+              </a:schemeClr>
+            </a:lnRef>
+            <a:fillRef idx="1">
+              <a:schemeClr val="accent1"/>
+            </a:fillRef>
+            <a:effectRef idx="0">
+              <a:schemeClr val="accent1"/>
+            </a:effectRef>
+            <a:fontRef idx="minor">
+              <a:schemeClr val="lt1"/>
+            </a:fontRef>
+          </p:style>
+          <p:txBody>
+            <a:bodyPr rtlCol="0" anchor="ctr"/>
+            <a:lstStyle/>
+            <a:p>
+              <a:pPr algn="ctr"/>
+              <a:endParaRPr lang="en-US"/>
+            </a:p>
+          </p:txBody>
+        </p:sp>
+      </p:grpSp>
+      <p:grpSp>
+        <p:nvGrpSpPr>
+          <p:cNvPr id="56" name="Group 55">
+            <a:extLst>
+              <a:ext uri="{FF2B5EF4-FFF2-40B4-BE49-F238E27FC236}">
+                <a16:creationId xmlns:a16="http://schemas.microsoft.com/office/drawing/2014/main" id="{4B83D932-ECCF-4940-AAE7-BFB735EC8F5A}"/>
+              </a:ext>
+            </a:extLst>
+          </p:cNvPr>
+          <p:cNvGrpSpPr/>
+          <p:nvPr/>
+        </p:nvGrpSpPr>
+        <p:grpSpPr>
+          <a:xfrm>
+            <a:off x="4801926" y="3664813"/>
+            <a:ext cx="400071" cy="622904"/>
+            <a:chOff x="8353816" y="2915490"/>
+            <a:chExt cx="400071" cy="622904"/>
+          </a:xfrm>
+        </p:grpSpPr>
+        <p:sp>
+          <p:nvSpPr>
+            <p:cNvPr id="57" name="Chord 56">
+              <a:extLst>
+                <a:ext uri="{FF2B5EF4-FFF2-40B4-BE49-F238E27FC236}">
+                  <a16:creationId xmlns:a16="http://schemas.microsoft.com/office/drawing/2014/main" id="{E6608653-86C5-424B-93A2-4528B70AA2E4}"/>
+                </a:ext>
+              </a:extLst>
+            </p:cNvPr>
+            <p:cNvSpPr/>
+            <p:nvPr/>
+          </p:nvSpPr>
+          <p:spPr>
+            <a:xfrm rot="5801687">
+              <a:off x="8369315" y="2899991"/>
+              <a:ext cx="255722" cy="286719"/>
+            </a:xfrm>
+            <a:prstGeom prst="chord">
+              <a:avLst/>
+            </a:prstGeom>
+            <a:solidFill>
+              <a:srgbClr val="00B050"/>
+            </a:solidFill>
+          </p:spPr>
+          <p:style>
+            <a:lnRef idx="2">
+              <a:schemeClr val="accent1">
+                <a:shade val="50000"/>
+              </a:schemeClr>
+            </a:lnRef>
+            <a:fillRef idx="1">
+              <a:schemeClr val="accent1"/>
+            </a:fillRef>
+            <a:effectRef idx="0">
+              <a:schemeClr val="accent1"/>
+            </a:effectRef>
+            <a:fontRef idx="minor">
+              <a:schemeClr val="lt1"/>
+            </a:fontRef>
+          </p:style>
+          <p:txBody>
+            <a:bodyPr rtlCol="0" anchor="ctr"/>
+            <a:lstStyle/>
+            <a:p>
+              <a:pPr algn="ctr"/>
+              <a:endParaRPr lang="en-US"/>
+            </a:p>
+          </p:txBody>
+        </p:sp>
+        <p:sp>
+          <p:nvSpPr>
+            <p:cNvPr id="58" name="Chord 57">
+              <a:extLst>
+                <a:ext uri="{FF2B5EF4-FFF2-40B4-BE49-F238E27FC236}">
+                  <a16:creationId xmlns:a16="http://schemas.microsoft.com/office/drawing/2014/main" id="{4C389952-0113-CE46-8E54-DBC1CC389703}"/>
+                </a:ext>
+              </a:extLst>
+            </p:cNvPr>
+            <p:cNvSpPr/>
+            <p:nvPr/>
+          </p:nvSpPr>
+          <p:spPr>
+            <a:xfrm rot="5789241" flipH="1" flipV="1">
+              <a:off x="8482667" y="3267173"/>
+              <a:ext cx="255722" cy="286719"/>
+            </a:xfrm>
+            <a:prstGeom prst="chord">
+              <a:avLst/>
+            </a:prstGeom>
+            <a:solidFill>
+              <a:srgbClr val="FFFF00"/>
+            </a:solidFill>
+          </p:spPr>
+          <p:style>
+            <a:lnRef idx="2">
+              <a:schemeClr val="accent1">
+                <a:shade val="50000"/>
+              </a:schemeClr>
+            </a:lnRef>
+            <a:fillRef idx="1">
+              <a:schemeClr val="accent1"/>
+            </a:fillRef>
+            <a:effectRef idx="0">
+              <a:schemeClr val="accent1"/>
+            </a:effectRef>
+            <a:fontRef idx="minor">
+              <a:schemeClr val="lt1"/>
+            </a:fontRef>
+          </p:style>
+          <p:txBody>
+            <a:bodyPr rtlCol="0" anchor="ctr"/>
+            <a:lstStyle/>
+            <a:p>
+              <a:pPr algn="ctr"/>
+              <a:endParaRPr lang="en-US"/>
+            </a:p>
+          </p:txBody>
+        </p:sp>
+      </p:grpSp>
+      <p:sp>
+        <p:nvSpPr>
+          <p:cNvPr id="60" name="Chord 59">
+            <a:extLst>
+              <a:ext uri="{FF2B5EF4-FFF2-40B4-BE49-F238E27FC236}">
+                <a16:creationId xmlns:a16="http://schemas.microsoft.com/office/drawing/2014/main" id="{EB330ADE-173A-E54A-8C0A-5D327291BD49}"/>
+              </a:ext>
+            </a:extLst>
+          </p:cNvPr>
+          <p:cNvSpPr/>
+          <p:nvPr/>
+        </p:nvSpPr>
+        <p:spPr>
+          <a:xfrm rot="5789241" flipH="1" flipV="1">
+            <a:off x="6321715" y="3638727"/>
+            <a:ext cx="255722" cy="286719"/>
+          </a:xfrm>
+          <a:prstGeom prst="chord">
+            <a:avLst/>
+          </a:prstGeom>
+          <a:solidFill>
+            <a:srgbClr val="FFFF00"/>
+          </a:solidFill>
+        </p:spPr>
+        <p:style>
+          <a:lnRef idx="2">
+            <a:schemeClr val="accent1">
+              <a:shade val="50000"/>
+            </a:schemeClr>
+          </a:lnRef>
+          <a:fillRef idx="1">
+            <a:schemeClr val="accent1"/>
+          </a:fillRef>
+          <a:effectRef idx="0">
+            <a:schemeClr val="accent1"/>
+          </a:effectRef>
+          <a:fontRef idx="minor">
+            <a:schemeClr val="lt1"/>
+          </a:fontRef>
+        </p:style>
+        <p:txBody>
+          <a:bodyPr rtlCol="0" anchor="ctr"/>
+          <a:lstStyle/>
+          <a:p>
+            <a:pPr algn="ctr"/>
+            <a:endParaRPr lang="en-US"/>
+          </a:p>
+        </p:txBody>
+      </p:sp>
+      <p:sp>
+        <p:nvSpPr>
+          <p:cNvPr id="67" name="Chord 66">
+            <a:extLst>
+              <a:ext uri="{FF2B5EF4-FFF2-40B4-BE49-F238E27FC236}">
+                <a16:creationId xmlns:a16="http://schemas.microsoft.com/office/drawing/2014/main" id="{B6021617-B670-F544-BA19-41C3B1141319}"/>
+              </a:ext>
+            </a:extLst>
+          </p:cNvPr>
+          <p:cNvSpPr/>
+          <p:nvPr/>
+        </p:nvSpPr>
+        <p:spPr>
+          <a:xfrm rot="5801687">
+            <a:off x="6211914" y="3269400"/>
+            <a:ext cx="255722" cy="286719"/>
+          </a:xfrm>
+          <a:prstGeom prst="chord">
+            <a:avLst/>
+          </a:prstGeom>
+          <a:solidFill>
+            <a:srgbClr val="00B050"/>
+          </a:solidFill>
+        </p:spPr>
+        <p:style>
+          <a:lnRef idx="2">
+            <a:schemeClr val="accent1">
+              <a:shade val="50000"/>
+            </a:schemeClr>
+          </a:lnRef>
+          <a:fillRef idx="1">
+            <a:schemeClr val="accent1"/>
+          </a:fillRef>
+          <a:effectRef idx="0">
+            <a:schemeClr val="accent1"/>
+          </a:effectRef>
+          <a:fontRef idx="minor">
+            <a:schemeClr val="lt1"/>
+          </a:fontRef>
+        </p:style>
+        <p:txBody>
+          <a:bodyPr rtlCol="0" anchor="ctr"/>
+          <a:lstStyle/>
+          <a:p>
+            <a:pPr algn="ctr"/>
+            <a:endParaRPr lang="en-US"/>
+          </a:p>
+        </p:txBody>
+      </p:sp>
+      <p:sp>
+        <p:nvSpPr>
+          <p:cNvPr id="3" name="Oval 2">
+            <a:extLst>
+              <a:ext uri="{FF2B5EF4-FFF2-40B4-BE49-F238E27FC236}">
+                <a16:creationId xmlns:a16="http://schemas.microsoft.com/office/drawing/2014/main" id="{99C1B4F7-29AD-EB4F-B1C4-E3A35BF22A95}"/>
+              </a:ext>
+            </a:extLst>
+          </p:cNvPr>
+          <p:cNvSpPr/>
+          <p:nvPr/>
+        </p:nvSpPr>
+        <p:spPr>
+          <a:xfrm>
+            <a:off x="8985054" y="2712203"/>
+            <a:ext cx="294468" cy="278970"/>
+          </a:xfrm>
+          <a:prstGeom prst="ellipse">
+            <a:avLst/>
+          </a:prstGeom>
+          <a:solidFill>
+            <a:srgbClr val="00B050"/>
+          </a:solidFill>
+        </p:spPr>
+        <p:style>
+          <a:lnRef idx="2">
+            <a:schemeClr val="accent1">
+              <a:shade val="50000"/>
+            </a:schemeClr>
+          </a:lnRef>
+          <a:fillRef idx="1">
+            <a:schemeClr val="accent1"/>
+          </a:fillRef>
+          <a:effectRef idx="0">
+            <a:schemeClr val="accent1"/>
+          </a:effectRef>
+          <a:fontRef idx="minor">
+            <a:schemeClr val="lt1"/>
+          </a:fontRef>
+        </p:style>
+        <p:txBody>
+          <a:bodyPr rtlCol="0" anchor="ctr"/>
+          <a:lstStyle/>
+          <a:p>
+            <a:pPr algn="ctr"/>
+            <a:endParaRPr lang="en-US"/>
+          </a:p>
+        </p:txBody>
+      </p:sp>
+      <p:sp>
+        <p:nvSpPr>
+          <p:cNvPr id="59" name="Oval 58">
+            <a:extLst>
+              <a:ext uri="{FF2B5EF4-FFF2-40B4-BE49-F238E27FC236}">
+                <a16:creationId xmlns:a16="http://schemas.microsoft.com/office/drawing/2014/main" id="{438EBBFA-45B5-9448-BB58-3E21FEE0C4CA}"/>
+              </a:ext>
+            </a:extLst>
+          </p:cNvPr>
+          <p:cNvSpPr/>
+          <p:nvPr/>
+        </p:nvSpPr>
+        <p:spPr>
+          <a:xfrm>
+            <a:off x="3467635" y="4179376"/>
+            <a:ext cx="294468" cy="278970"/>
+          </a:xfrm>
+          <a:prstGeom prst="ellipse">
+            <a:avLst/>
+          </a:prstGeom>
+          <a:solidFill>
+            <a:srgbClr val="00B050"/>
+          </a:solidFill>
+        </p:spPr>
+        <p:style>
+          <a:lnRef idx="2">
+            <a:schemeClr val="accent1">
+              <a:shade val="50000"/>
+            </a:schemeClr>
+          </a:lnRef>
+          <a:fillRef idx="1">
+            <a:schemeClr val="accent1"/>
+          </a:fillRef>
+          <a:effectRef idx="0">
+            <a:schemeClr val="accent1"/>
+          </a:effectRef>
+          <a:fontRef idx="minor">
+            <a:schemeClr val="lt1"/>
+          </a:fontRef>
+        </p:style>
+        <p:txBody>
+          <a:bodyPr rtlCol="0" anchor="ctr"/>
+          <a:lstStyle/>
+          <a:p>
+            <a:pPr algn="ctr"/>
+            <a:endParaRPr lang="en-US"/>
+          </a:p>
+        </p:txBody>
+      </p:sp>
+      <p:sp>
+        <p:nvSpPr>
+          <p:cNvPr id="97" name="TextBox 96">
+            <a:extLst>
+              <a:ext uri="{FF2B5EF4-FFF2-40B4-BE49-F238E27FC236}">
+                <a16:creationId xmlns:a16="http://schemas.microsoft.com/office/drawing/2014/main" id="{7C9B76D4-C3E5-3243-817C-DA17FB75959C}"/>
+              </a:ext>
+            </a:extLst>
+          </p:cNvPr>
+          <p:cNvSpPr txBox="1"/>
+          <p:nvPr/>
+        </p:nvSpPr>
+        <p:spPr>
+          <a:xfrm>
+            <a:off x="4901750" y="2836730"/>
+            <a:ext cx="1925527" cy="400110"/>
+          </a:xfrm>
+          <a:prstGeom prst="rect">
+            <a:avLst/>
+          </a:prstGeom>
+          <a:solidFill>
+            <a:srgbClr val="FFFFFF">
+              <a:alpha val="80000"/>
+            </a:srgbClr>
+          </a:solidFill>
+        </p:spPr>
+        <p:txBody>
+          <a:bodyPr wrap="none" rtlCol="0">
+            <a:spAutoFit/>
+          </a:bodyPr>
+          <a:lstStyle/>
+          <a:p>
+            <a:r>
+              <a:rPr lang="en-US" sz="2000" dirty="0">
+                <a:solidFill>
+                  <a:srgbClr val="0070C0"/>
+                </a:solidFill>
+                <a:latin typeface="Arial" panose="020B0604020202020204" pitchFamily="34" charset="0"/>
+                <a:cs typeface="Arial" panose="020B0604020202020204" pitchFamily="34" charset="0"/>
+              </a:rPr>
+              <a:t>SplitBoundary1</a:t>
+            </a:r>
+          </a:p>
+        </p:txBody>
+      </p:sp>
+      <p:sp>
+        <p:nvSpPr>
+          <p:cNvPr id="4" name="TextBox 3">
+            <a:extLst>
+              <a:ext uri="{FF2B5EF4-FFF2-40B4-BE49-F238E27FC236}">
+                <a16:creationId xmlns:a16="http://schemas.microsoft.com/office/drawing/2014/main" id="{A4305E1F-E7A9-FB40-BDBA-8B687BCFB7C2}"/>
+              </a:ext>
+            </a:extLst>
+          </p:cNvPr>
+          <p:cNvSpPr txBox="1"/>
+          <p:nvPr/>
+        </p:nvSpPr>
+        <p:spPr>
+          <a:xfrm>
+            <a:off x="8826285" y="5974597"/>
+            <a:ext cx="1053686" cy="369332"/>
+          </a:xfrm>
+          <a:prstGeom prst="rect">
+            <a:avLst/>
+          </a:prstGeom>
+          <a:noFill/>
+        </p:spPr>
+        <p:txBody>
+          <a:bodyPr wrap="none" rtlCol="0">
+            <a:spAutoFit/>
+          </a:bodyPr>
+          <a:lstStyle/>
+          <a:p>
+            <a:r>
+              <a:rPr lang="en-US" dirty="0"/>
+              <a:t>Figure 14</a:t>
+            </a:r>
+          </a:p>
+        </p:txBody>
+      </p:sp>
+      <p:cxnSp>
+        <p:nvCxnSpPr>
+          <p:cNvPr id="10" name="Straight Connector 9">
+            <a:extLst>
+              <a:ext uri="{FF2B5EF4-FFF2-40B4-BE49-F238E27FC236}">
+                <a16:creationId xmlns:a16="http://schemas.microsoft.com/office/drawing/2014/main" id="{FA904DE0-A38F-C44F-902B-147A75C5760B}"/>
+              </a:ext>
+            </a:extLst>
+          </p:cNvPr>
+          <p:cNvCxnSpPr>
+            <a:cxnSpLocks/>
+          </p:cNvCxnSpPr>
+          <p:nvPr/>
+        </p:nvCxnSpPr>
+        <p:spPr>
+          <a:xfrm flipV="1">
+            <a:off x="3762103" y="2888264"/>
+            <a:ext cx="5222951" cy="1414832"/>
+          </a:xfrm>
+          <a:prstGeom prst="line">
+            <a:avLst/>
+          </a:prstGeom>
+          <a:ln w="38100">
+            <a:solidFill>
+              <a:schemeClr val="accent4">
+                <a:lumMod val="20000"/>
+                <a:lumOff val="80000"/>
+              </a:schemeClr>
+            </a:solidFill>
+          </a:ln>
+        </p:spPr>
+        <p:style>
+          <a:lnRef idx="1">
+            <a:schemeClr val="accent1"/>
+          </a:lnRef>
+          <a:fillRef idx="0">
+            <a:schemeClr val="accent1"/>
+          </a:fillRef>
+          <a:effectRef idx="0">
+            <a:schemeClr val="accent1"/>
+          </a:effectRef>
+          <a:fontRef idx="minor">
+            <a:schemeClr val="tx1"/>
+          </a:fontRef>
+        </p:style>
+      </p:cxnSp>
+      <p:sp>
+        <p:nvSpPr>
+          <p:cNvPr id="64" name="Oval 63">
+            <a:extLst>
+              <a:ext uri="{FF2B5EF4-FFF2-40B4-BE49-F238E27FC236}">
+                <a16:creationId xmlns:a16="http://schemas.microsoft.com/office/drawing/2014/main" id="{35BEDE53-7090-BF4A-BDAF-BCEAB4F92A05}"/>
+              </a:ext>
+            </a:extLst>
+          </p:cNvPr>
+          <p:cNvSpPr/>
+          <p:nvPr/>
+        </p:nvSpPr>
+        <p:spPr>
+          <a:xfrm>
+            <a:off x="3620035" y="4148896"/>
+            <a:ext cx="294468" cy="278970"/>
+          </a:xfrm>
+          <a:prstGeom prst="ellipse">
+            <a:avLst/>
+          </a:prstGeom>
+          <a:solidFill>
+            <a:srgbClr val="FFC000"/>
+          </a:solidFill>
+        </p:spPr>
+        <p:style>
+          <a:lnRef idx="2">
+            <a:schemeClr val="accent1">
+              <a:shade val="50000"/>
+            </a:schemeClr>
+          </a:lnRef>
+          <a:fillRef idx="1">
+            <a:schemeClr val="accent1"/>
+          </a:fillRef>
+          <a:effectRef idx="0">
+            <a:schemeClr val="accent1"/>
+          </a:effectRef>
+          <a:fontRef idx="minor">
+            <a:schemeClr val="lt1"/>
+          </a:fontRef>
+        </p:style>
+        <p:txBody>
+          <a:bodyPr rtlCol="0" anchor="ctr"/>
+          <a:lstStyle/>
+          <a:p>
+            <a:pPr algn="ctr"/>
+            <a:endParaRPr lang="en-US"/>
+          </a:p>
+        </p:txBody>
+      </p:sp>
+      <p:sp>
+        <p:nvSpPr>
+          <p:cNvPr id="65" name="Oval 64">
+            <a:extLst>
+              <a:ext uri="{FF2B5EF4-FFF2-40B4-BE49-F238E27FC236}">
+                <a16:creationId xmlns:a16="http://schemas.microsoft.com/office/drawing/2014/main" id="{F4F67782-B4D2-224A-A466-3A124CF28060}"/>
+              </a:ext>
+            </a:extLst>
+          </p:cNvPr>
+          <p:cNvSpPr/>
+          <p:nvPr/>
+        </p:nvSpPr>
+        <p:spPr>
+          <a:xfrm>
+            <a:off x="4198817" y="3996864"/>
+            <a:ext cx="294468" cy="278970"/>
+          </a:xfrm>
+          <a:prstGeom prst="ellipse">
+            <a:avLst/>
+          </a:prstGeom>
+          <a:solidFill>
+            <a:schemeClr val="accent4">
+              <a:lumMod val="40000"/>
+              <a:lumOff val="60000"/>
+            </a:schemeClr>
+          </a:solidFill>
+        </p:spPr>
+        <p:style>
+          <a:lnRef idx="2">
+            <a:schemeClr val="accent1">
+              <a:shade val="50000"/>
+            </a:schemeClr>
+          </a:lnRef>
+          <a:fillRef idx="1">
+            <a:schemeClr val="accent1"/>
+          </a:fillRef>
+          <a:effectRef idx="0">
+            <a:schemeClr val="accent1"/>
+          </a:effectRef>
+          <a:fontRef idx="minor">
+            <a:schemeClr val="lt1"/>
+          </a:fontRef>
+        </p:style>
+        <p:txBody>
+          <a:bodyPr rtlCol="0" anchor="ctr"/>
+          <a:lstStyle/>
+          <a:p>
+            <a:pPr algn="ctr"/>
+            <a:endParaRPr lang="en-US"/>
+          </a:p>
+        </p:txBody>
+      </p:sp>
+      <p:sp>
+        <p:nvSpPr>
+          <p:cNvPr id="66" name="Oval 65">
+            <a:extLst>
+              <a:ext uri="{FF2B5EF4-FFF2-40B4-BE49-F238E27FC236}">
+                <a16:creationId xmlns:a16="http://schemas.microsoft.com/office/drawing/2014/main" id="{742B841B-AF23-334D-BC0A-0A90B6BB589D}"/>
+              </a:ext>
+            </a:extLst>
+          </p:cNvPr>
+          <p:cNvSpPr/>
+          <p:nvPr/>
+        </p:nvSpPr>
+        <p:spPr>
+          <a:xfrm>
+            <a:off x="4856847" y="3844832"/>
+            <a:ext cx="294468" cy="278970"/>
+          </a:xfrm>
+          <a:prstGeom prst="ellipse">
+            <a:avLst/>
+          </a:prstGeom>
+          <a:solidFill>
+            <a:schemeClr val="accent4">
+              <a:lumMod val="40000"/>
+              <a:lumOff val="60000"/>
+            </a:schemeClr>
+          </a:solidFill>
+        </p:spPr>
+        <p:style>
+          <a:lnRef idx="2">
+            <a:schemeClr val="accent1">
+              <a:shade val="50000"/>
+            </a:schemeClr>
+          </a:lnRef>
+          <a:fillRef idx="1">
+            <a:schemeClr val="accent1"/>
+          </a:fillRef>
+          <a:effectRef idx="0">
+            <a:schemeClr val="accent1"/>
+          </a:effectRef>
+          <a:fontRef idx="minor">
+            <a:schemeClr val="lt1"/>
+          </a:fontRef>
+        </p:style>
+        <p:txBody>
+          <a:bodyPr rtlCol="0" anchor="ctr"/>
+          <a:lstStyle/>
+          <a:p>
+            <a:pPr algn="ctr"/>
+            <a:endParaRPr lang="en-US"/>
+          </a:p>
+        </p:txBody>
+      </p:sp>
+      <p:sp>
+        <p:nvSpPr>
+          <p:cNvPr id="95" name="Oval 94">
+            <a:extLst>
+              <a:ext uri="{FF2B5EF4-FFF2-40B4-BE49-F238E27FC236}">
+                <a16:creationId xmlns:a16="http://schemas.microsoft.com/office/drawing/2014/main" id="{99AFAE78-4FE0-314F-9C4E-912CE06FA16C}"/>
+              </a:ext>
+            </a:extLst>
+          </p:cNvPr>
+          <p:cNvSpPr/>
+          <p:nvPr/>
+        </p:nvSpPr>
+        <p:spPr>
+          <a:xfrm>
+            <a:off x="5557549" y="3656224"/>
+            <a:ext cx="294468" cy="278970"/>
+          </a:xfrm>
+          <a:prstGeom prst="ellipse">
+            <a:avLst/>
+          </a:prstGeom>
+          <a:solidFill>
+            <a:schemeClr val="accent4">
+              <a:lumMod val="40000"/>
+              <a:lumOff val="60000"/>
+            </a:schemeClr>
+          </a:solidFill>
+        </p:spPr>
+        <p:style>
+          <a:lnRef idx="2">
+            <a:schemeClr val="accent1">
+              <a:shade val="50000"/>
+            </a:schemeClr>
+          </a:lnRef>
+          <a:fillRef idx="1">
+            <a:schemeClr val="accent1"/>
+          </a:fillRef>
+          <a:effectRef idx="0">
+            <a:schemeClr val="accent1"/>
+          </a:effectRef>
+          <a:fontRef idx="minor">
+            <a:schemeClr val="lt1"/>
+          </a:fontRef>
+        </p:style>
+        <p:txBody>
+          <a:bodyPr rtlCol="0" anchor="ctr"/>
+          <a:lstStyle/>
+          <a:p>
+            <a:pPr algn="ctr"/>
+            <a:endParaRPr lang="en-US"/>
+          </a:p>
+        </p:txBody>
+      </p:sp>
+      <p:sp>
+        <p:nvSpPr>
+          <p:cNvPr id="100" name="Oval 99">
+            <a:extLst>
+              <a:ext uri="{FF2B5EF4-FFF2-40B4-BE49-F238E27FC236}">
+                <a16:creationId xmlns:a16="http://schemas.microsoft.com/office/drawing/2014/main" id="{71D3202A-D81B-F34E-A473-401054A8A615}"/>
+              </a:ext>
+            </a:extLst>
+          </p:cNvPr>
+          <p:cNvSpPr/>
+          <p:nvPr/>
+        </p:nvSpPr>
+        <p:spPr>
+          <a:xfrm>
+            <a:off x="6258251" y="3467616"/>
+            <a:ext cx="294468" cy="278970"/>
+          </a:xfrm>
+          <a:prstGeom prst="ellipse">
+            <a:avLst/>
+          </a:prstGeom>
+          <a:solidFill>
+            <a:schemeClr val="accent4">
+              <a:lumMod val="40000"/>
+              <a:lumOff val="60000"/>
+            </a:schemeClr>
+          </a:solidFill>
+        </p:spPr>
+        <p:style>
+          <a:lnRef idx="2">
+            <a:schemeClr val="accent1">
+              <a:shade val="50000"/>
+            </a:schemeClr>
+          </a:lnRef>
+          <a:fillRef idx="1">
+            <a:schemeClr val="accent1"/>
+          </a:fillRef>
+          <a:effectRef idx="0">
+            <a:schemeClr val="accent1"/>
+          </a:effectRef>
+          <a:fontRef idx="minor">
+            <a:schemeClr val="lt1"/>
+          </a:fontRef>
+        </p:style>
+        <p:txBody>
+          <a:bodyPr rtlCol="0" anchor="ctr"/>
+          <a:lstStyle/>
+          <a:p>
+            <a:pPr algn="ctr"/>
+            <a:endParaRPr lang="en-US"/>
+          </a:p>
+        </p:txBody>
+      </p:sp>
+      <p:sp>
+        <p:nvSpPr>
+          <p:cNvPr id="101" name="Oval 100">
+            <a:extLst>
+              <a:ext uri="{FF2B5EF4-FFF2-40B4-BE49-F238E27FC236}">
+                <a16:creationId xmlns:a16="http://schemas.microsoft.com/office/drawing/2014/main" id="{68836C48-465C-434D-A2A4-9A46FF91A851}"/>
+              </a:ext>
+            </a:extLst>
+          </p:cNvPr>
+          <p:cNvSpPr/>
+          <p:nvPr/>
+        </p:nvSpPr>
+        <p:spPr>
+          <a:xfrm>
+            <a:off x="6897993" y="3279008"/>
+            <a:ext cx="294468" cy="278970"/>
+          </a:xfrm>
+          <a:prstGeom prst="ellipse">
+            <a:avLst/>
+          </a:prstGeom>
+          <a:solidFill>
+            <a:schemeClr val="accent4">
+              <a:lumMod val="40000"/>
+              <a:lumOff val="60000"/>
+            </a:schemeClr>
+          </a:solidFill>
+        </p:spPr>
+        <p:style>
+          <a:lnRef idx="2">
+            <a:schemeClr val="accent1">
+              <a:shade val="50000"/>
+            </a:schemeClr>
+          </a:lnRef>
+          <a:fillRef idx="1">
+            <a:schemeClr val="accent1"/>
+          </a:fillRef>
+          <a:effectRef idx="0">
+            <a:schemeClr val="accent1"/>
+          </a:effectRef>
+          <a:fontRef idx="minor">
+            <a:schemeClr val="lt1"/>
+          </a:fontRef>
+        </p:style>
+        <p:txBody>
+          <a:bodyPr rtlCol="0" anchor="ctr"/>
+          <a:lstStyle/>
+          <a:p>
+            <a:pPr algn="ctr"/>
+            <a:endParaRPr lang="en-US"/>
+          </a:p>
+        </p:txBody>
+      </p:sp>
+      <p:sp>
+        <p:nvSpPr>
+          <p:cNvPr id="102" name="Oval 101">
+            <a:extLst>
+              <a:ext uri="{FF2B5EF4-FFF2-40B4-BE49-F238E27FC236}">
+                <a16:creationId xmlns:a16="http://schemas.microsoft.com/office/drawing/2014/main" id="{01AB249A-2C3D-C943-9CBC-A84B89535C2F}"/>
+              </a:ext>
+            </a:extLst>
+          </p:cNvPr>
+          <p:cNvSpPr/>
+          <p:nvPr/>
+        </p:nvSpPr>
+        <p:spPr>
+          <a:xfrm>
+            <a:off x="7574311" y="3108688"/>
+            <a:ext cx="294468" cy="278970"/>
+          </a:xfrm>
+          <a:prstGeom prst="ellipse">
+            <a:avLst/>
+          </a:prstGeom>
+          <a:solidFill>
+            <a:schemeClr val="accent4">
+              <a:lumMod val="40000"/>
+              <a:lumOff val="60000"/>
+            </a:schemeClr>
+          </a:solidFill>
+        </p:spPr>
+        <p:style>
+          <a:lnRef idx="2">
+            <a:schemeClr val="accent1">
+              <a:shade val="50000"/>
+            </a:schemeClr>
+          </a:lnRef>
+          <a:fillRef idx="1">
+            <a:schemeClr val="accent1"/>
+          </a:fillRef>
+          <a:effectRef idx="0">
+            <a:schemeClr val="accent1"/>
+          </a:effectRef>
+          <a:fontRef idx="minor">
+            <a:schemeClr val="lt1"/>
+          </a:fontRef>
+        </p:style>
+        <p:txBody>
+          <a:bodyPr rtlCol="0" anchor="ctr"/>
+          <a:lstStyle/>
+          <a:p>
+            <a:pPr algn="ctr"/>
+            <a:endParaRPr lang="en-US"/>
+          </a:p>
+        </p:txBody>
+      </p:sp>
+      <p:sp>
+        <p:nvSpPr>
+          <p:cNvPr id="103" name="Oval 102">
+            <a:extLst>
+              <a:ext uri="{FF2B5EF4-FFF2-40B4-BE49-F238E27FC236}">
+                <a16:creationId xmlns:a16="http://schemas.microsoft.com/office/drawing/2014/main" id="{42568D25-4F61-5E4D-9ADC-8BE677F64A94}"/>
+              </a:ext>
+            </a:extLst>
+          </p:cNvPr>
+          <p:cNvSpPr/>
+          <p:nvPr/>
+        </p:nvSpPr>
+        <p:spPr>
+          <a:xfrm>
+            <a:off x="8250629" y="2907888"/>
+            <a:ext cx="294468" cy="278970"/>
+          </a:xfrm>
+          <a:prstGeom prst="ellipse">
+            <a:avLst/>
+          </a:prstGeom>
+          <a:solidFill>
+            <a:schemeClr val="accent4">
+              <a:lumMod val="40000"/>
+              <a:lumOff val="60000"/>
+            </a:schemeClr>
+          </a:solidFill>
+        </p:spPr>
+        <p:style>
+          <a:lnRef idx="2">
+            <a:schemeClr val="accent1">
+              <a:shade val="50000"/>
+            </a:schemeClr>
+          </a:lnRef>
+          <a:fillRef idx="1">
+            <a:schemeClr val="accent1"/>
+          </a:fillRef>
+          <a:effectRef idx="0">
+            <a:schemeClr val="accent1"/>
+          </a:effectRef>
+          <a:fontRef idx="minor">
+            <a:schemeClr val="lt1"/>
+          </a:fontRef>
+        </p:style>
+        <p:txBody>
+          <a:bodyPr rtlCol="0" anchor="ctr"/>
+          <a:lstStyle/>
+          <a:p>
+            <a:pPr algn="ctr"/>
+            <a:endParaRPr lang="en-US"/>
+          </a:p>
+        </p:txBody>
+      </p:sp>
+      <p:sp>
+        <p:nvSpPr>
+          <p:cNvPr id="104" name="Oval 103">
+            <a:extLst>
+              <a:ext uri="{FF2B5EF4-FFF2-40B4-BE49-F238E27FC236}">
+                <a16:creationId xmlns:a16="http://schemas.microsoft.com/office/drawing/2014/main" id="{BE1199CD-8117-A14D-8798-8095956DD20D}"/>
+              </a:ext>
+            </a:extLst>
+          </p:cNvPr>
+          <p:cNvSpPr/>
+          <p:nvPr/>
+        </p:nvSpPr>
+        <p:spPr>
+          <a:xfrm>
+            <a:off x="8926947" y="2707088"/>
+            <a:ext cx="294468" cy="278970"/>
+          </a:xfrm>
+          <a:prstGeom prst="ellipse">
+            <a:avLst/>
+          </a:prstGeom>
+          <a:solidFill>
+            <a:srgbClr val="FFC000"/>
+          </a:solidFill>
+        </p:spPr>
+        <p:style>
+          <a:lnRef idx="2">
+            <a:schemeClr val="accent1">
+              <a:shade val="50000"/>
+            </a:schemeClr>
+          </a:lnRef>
+          <a:fillRef idx="1">
+            <a:schemeClr val="accent1"/>
+          </a:fillRef>
+          <a:effectRef idx="0">
+            <a:schemeClr val="accent1"/>
+          </a:effectRef>
+          <a:fontRef idx="minor">
+            <a:schemeClr val="lt1"/>
+          </a:fontRef>
+        </p:style>
+        <p:txBody>
+          <a:bodyPr rtlCol="0" anchor="ctr"/>
+          <a:lstStyle/>
+          <a:p>
+            <a:pPr algn="ctr"/>
+            <a:endParaRPr lang="en-US"/>
+          </a:p>
+        </p:txBody>
+      </p:sp>
+      <p:sp>
+        <p:nvSpPr>
+          <p:cNvPr id="105" name="TextBox 104">
+            <a:extLst>
+              <a:ext uri="{FF2B5EF4-FFF2-40B4-BE49-F238E27FC236}">
+                <a16:creationId xmlns:a16="http://schemas.microsoft.com/office/drawing/2014/main" id="{73D8D194-4EAD-4146-A64B-5616458F0E2B}"/>
+              </a:ext>
+            </a:extLst>
+          </p:cNvPr>
+          <p:cNvSpPr txBox="1"/>
+          <p:nvPr/>
+        </p:nvSpPr>
+        <p:spPr>
+          <a:xfrm>
+            <a:off x="8622310" y="2885346"/>
+            <a:ext cx="1212191" cy="400110"/>
+          </a:xfrm>
+          <a:prstGeom prst="rect">
+            <a:avLst/>
+          </a:prstGeom>
+          <a:solidFill>
+            <a:srgbClr val="FFFFFF">
+              <a:alpha val="80000"/>
+            </a:srgbClr>
+          </a:solidFill>
+        </p:spPr>
+        <p:txBody>
+          <a:bodyPr wrap="none" rtlCol="0">
+            <a:spAutoFit/>
+          </a:bodyPr>
+          <a:lstStyle/>
+          <a:p>
+            <a:r>
+              <a:rPr lang="en-US" sz="2000" dirty="0">
+                <a:solidFill>
+                  <a:srgbClr val="FFC000"/>
+                </a:solidFill>
+                <a:latin typeface="Arial" panose="020B0604020202020204" pitchFamily="34" charset="0"/>
+                <a:cs typeface="Arial" panose="020B0604020202020204" pitchFamily="34" charset="0"/>
+              </a:rPr>
+              <a:t>Region 2</a:t>
+            </a:r>
+          </a:p>
+        </p:txBody>
+      </p:sp>
+    </p:spTree>
+    <p:extLst>
+      <p:ext uri="{BB962C8B-B14F-4D97-AF65-F5344CB8AC3E}">
+        <p14:creationId xmlns:p14="http://schemas.microsoft.com/office/powerpoint/2010/main" val="749953729"/>
+      </p:ext>
+    </p:extLst>
+  </p:cSld>
+  <p:clrMapOvr>
+    <a:masterClrMapping/>
+  </p:clrMapOvr>
+</p:sld>
+</file>
+
 <file path=ppt/theme/theme1.xml><?xml version="1.0" encoding="utf-8"?>
 <a:theme xmlns:a="http://schemas.openxmlformats.org/drawingml/2006/main" name="Office Theme">
   <a:themeElements>

</xml_diff>